<commit_message>
docs(ppt): fix run/paragraph layout bug, measure-based bullet spacing, add slide previews and README
Co-authored-by: arena-agent <297053741+arena-agent@users.noreply.github.com>
</commit_message>
<xml_diff>
--- a/docs/ppt/SIH2026_IDEA_CAPACITY_CONNECT_26075.pptx
+++ b/docs/ppt/SIH2026_IDEA_CAPACITY_CONNECT_26075.pptx
@@ -5564,7 +5564,7 @@
               </a:spcAft>
             </a:pPr>
             <a:r>
-              <a:rPr sz="1050" b="1">
+              <a:rPr sz="1000" b="1">
                 <a:solidFill>
                   <a:srgbClr val="1F3864"/>
                 </a:solidFill>
@@ -5572,18 +5572,8 @@
               </a:rPr>
               <a:t>Single portal, three roles. </a:t>
             </a:r>
-          </a:p>
-          <a:p>
-            <a:pPr algn="l">
-              <a:lnSpc>
-                <a:spcPct val="112000"/>
-              </a:lnSpc>
-              <a:spcAft>
-                <a:spcPts val="300"/>
-              </a:spcAft>
-            </a:pPr>
-            <a:r>
-              <a:rPr sz="1050" b="0">
+            <a:r>
+              <a:rPr sz="1000" b="0">
                 <a:solidFill>
                   <a:srgbClr val="444C57"/>
                 </a:solidFill>
@@ -5602,7 +5592,7 @@
         </p:nvSpPr>
         <p:spPr>
           <a:xfrm>
-            <a:off x="566928" y="2683764"/>
+            <a:off x="566928" y="2703067"/>
             <a:ext cx="69850" cy="69850"/>
           </a:xfrm>
           <a:prstGeom prst="ellipse">
@@ -5646,7 +5636,7 @@
         </p:nvSpPr>
         <p:spPr>
           <a:xfrm>
-            <a:off x="749808" y="2633472"/>
+            <a:off x="749808" y="2652775"/>
             <a:ext cx="6583680" cy="365760"/>
           </a:xfrm>
           <a:prstGeom prst="rect">
@@ -5669,7 +5659,7 @@
               </a:spcAft>
             </a:pPr>
             <a:r>
-              <a:rPr sz="1050" b="1">
+              <a:rPr sz="1000" b="1">
                 <a:solidFill>
                   <a:srgbClr val="1F3864"/>
                 </a:solidFill>
@@ -5677,18 +5667,8 @@
               </a:rPr>
               <a:t>Trainee: </a:t>
             </a:r>
-          </a:p>
-          <a:p>
-            <a:pPr algn="l">
-              <a:lnSpc>
-                <a:spcPct val="112000"/>
-              </a:lnSpc>
-              <a:spcAft>
-                <a:spcPts val="300"/>
-              </a:spcAft>
-            </a:pPr>
-            <a:r>
-              <a:rPr sz="1050" b="0">
+            <a:r>
+              <a:rPr sz="1000" b="0">
                 <a:solidFill>
                   <a:srgbClr val="444C57"/>
                 </a:solidFill>
@@ -5707,7 +5687,7 @@
         </p:nvSpPr>
         <p:spPr>
           <a:xfrm>
-            <a:off x="566928" y="3122676"/>
+            <a:off x="566928" y="3161282"/>
             <a:ext cx="69850" cy="69850"/>
           </a:xfrm>
           <a:prstGeom prst="ellipse">
@@ -5751,7 +5731,7 @@
         </p:nvSpPr>
         <p:spPr>
           <a:xfrm>
-            <a:off x="749808" y="3072384"/>
+            <a:off x="749808" y="3110990"/>
             <a:ext cx="6583680" cy="365760"/>
           </a:xfrm>
           <a:prstGeom prst="rect">
@@ -5774,7 +5754,7 @@
               </a:spcAft>
             </a:pPr>
             <a:r>
-              <a:rPr sz="1050" b="1">
+              <a:rPr sz="1000" b="1">
                 <a:solidFill>
                   <a:srgbClr val="1F3864"/>
                 </a:solidFill>
@@ -5782,24 +5762,14 @@
               </a:rPr>
               <a:t>Trainer: </a:t>
             </a:r>
-          </a:p>
-          <a:p>
-            <a:pPr algn="l">
-              <a:lnSpc>
-                <a:spcPct val="112000"/>
-              </a:lnSpc>
-              <a:spcAft>
-                <a:spcPts val="300"/>
-              </a:spcAft>
-            </a:pPr>
-            <a:r>
-              <a:rPr sz="1050" b="0">
+            <a:r>
+              <a:rPr sz="1000" b="0">
                 <a:solidFill>
                   <a:srgbClr val="444C57"/>
                 </a:solidFill>
                 <a:latin typeface="Calibri"/>
               </a:rPr>
-              <a:t>profile &amp; competency declaration, questionnaires with deadlines, participation and performance monitoring, and a Trainer Library of recorded lectures, presentations and study material.</a:t>
+              <a:t>competency declaration, questionnaires with deadlines, participation and performance monitoring, and a Trainer Library of recorded lectures, presentations and study material.</a:t>
             </a:r>
           </a:p>
         </p:txBody>
@@ -5812,7 +5782,7 @@
         </p:nvSpPr>
         <p:spPr>
           <a:xfrm>
-            <a:off x="566928" y="3561588"/>
+            <a:off x="566928" y="3619497"/>
             <a:ext cx="69850" cy="69850"/>
           </a:xfrm>
           <a:prstGeom prst="ellipse">
@@ -5856,7 +5826,7 @@
         </p:nvSpPr>
         <p:spPr>
           <a:xfrm>
-            <a:off x="749808" y="3511296"/>
+            <a:off x="749808" y="3569205"/>
             <a:ext cx="6583680" cy="365760"/>
           </a:xfrm>
           <a:prstGeom prst="rect">
@@ -5879,7 +5849,7 @@
               </a:spcAft>
             </a:pPr>
             <a:r>
-              <a:rPr sz="1050" b="1">
+              <a:rPr sz="1000" b="1">
                 <a:solidFill>
                   <a:srgbClr val="1F3864"/>
                 </a:solidFill>
@@ -5887,24 +5857,14 @@
               </a:rPr>
               <a:t>Admin: </a:t>
             </a:r>
-          </a:p>
-          <a:p>
-            <a:pPr algn="l">
-              <a:lnSpc>
-                <a:spcPct val="112000"/>
-              </a:lnSpc>
-              <a:spcAft>
-                <a:spcPts val="300"/>
-              </a:spcAft>
-            </a:pPr>
-            <a:r>
-              <a:rPr sz="1050" b="0">
+            <a:r>
+              <a:rPr sz="1000" b="0">
                 <a:solidFill>
                   <a:srgbClr val="444C57"/>
                 </a:solidFill>
                 <a:latin typeface="Calibri"/>
               </a:rPr>
-              <a:t>user approval, dashboards for courses / enrollments / certifications / assessments / participation, and homepage publishing of notifications, announcements, achievements and new content.</a:t>
+              <a:t>user approval, role management, dashboards for courses / enrollments / certifications / assessments / participation, plus homepage publishing of notifications, announcements and achievements.</a:t>
             </a:r>
           </a:p>
         </p:txBody>
@@ -5917,7 +5877,7 @@
         </p:nvSpPr>
         <p:spPr>
           <a:xfrm>
-            <a:off x="566928" y="4000500"/>
+            <a:off x="566928" y="4077712"/>
             <a:ext cx="69850" cy="69850"/>
           </a:xfrm>
           <a:prstGeom prst="ellipse">
@@ -5961,7 +5921,7 @@
         </p:nvSpPr>
         <p:spPr>
           <a:xfrm>
-            <a:off x="749808" y="3950208"/>
+            <a:off x="749808" y="4027420"/>
             <a:ext cx="6583680" cy="365760"/>
           </a:xfrm>
           <a:prstGeom prst="rect">
@@ -5984,7 +5944,7 @@
               </a:spcAft>
             </a:pPr>
             <a:r>
-              <a:rPr sz="1050" b="1">
+              <a:rPr sz="1000" b="1">
                 <a:solidFill>
                   <a:srgbClr val="1F3864"/>
                 </a:solidFill>
@@ -5992,18 +5952,8 @@
               </a:rPr>
               <a:t>Competency mapping engine </a:t>
             </a:r>
-          </a:p>
-          <a:p>
-            <a:pPr algn="l">
-              <a:lnSpc>
-                <a:spcPct val="112000"/>
-              </a:lnSpc>
-              <a:spcAft>
-                <a:spcPts val="300"/>
-              </a:spcAft>
-            </a:pPr>
-            <a:r>
-              <a:rPr sz="1050" b="0">
+            <a:r>
+              <a:rPr sz="1000" b="0">
                 <a:solidFill>
                   <a:srgbClr val="444C57"/>
                 </a:solidFill>
@@ -6022,7 +5972,7 @@
         </p:nvSpPr>
         <p:spPr>
           <a:xfrm>
-            <a:off x="566928" y="4439412"/>
+            <a:off x="566928" y="4535927"/>
             <a:ext cx="69850" cy="69850"/>
           </a:xfrm>
           <a:prstGeom prst="ellipse">
@@ -6066,7 +6016,7 @@
         </p:nvSpPr>
         <p:spPr>
           <a:xfrm>
-            <a:off x="749808" y="4389120"/>
+            <a:off x="749808" y="4485635"/>
             <a:ext cx="6583680" cy="365760"/>
           </a:xfrm>
           <a:prstGeom prst="rect">
@@ -6089,7 +6039,7 @@
               </a:spcAft>
             </a:pPr>
             <a:r>
-              <a:rPr sz="1050" b="1">
+              <a:rPr sz="1000" b="1">
                 <a:solidFill>
                   <a:srgbClr val="1F3864"/>
                 </a:solidFill>
@@ -6097,18 +6047,8 @@
               </a:rPr>
               <a:t>Offline-first edge app: </a:t>
             </a:r>
-          </a:p>
-          <a:p>
-            <a:pPr algn="l">
-              <a:lnSpc>
-                <a:spcPct val="112000"/>
-              </a:lnSpc>
-              <a:spcAft>
-                <a:spcPts val="300"/>
-              </a:spcAft>
-            </a:pPr>
-            <a:r>
-              <a:rPr sz="1050" b="0">
+            <a:r>
+              <a:rPr sz="1000" b="0">
                 <a:solidFill>
                   <a:srgbClr val="444C57"/>
                 </a:solidFill>
@@ -6127,7 +6067,7 @@
         </p:nvSpPr>
         <p:spPr>
           <a:xfrm>
-            <a:off x="457200" y="4873752"/>
+            <a:off x="457200" y="4989570"/>
             <a:ext cx="6949440" cy="347472"/>
           </a:xfrm>
           <a:prstGeom prst="roundRect">
@@ -6173,7 +6113,7 @@
         </p:nvSpPr>
         <p:spPr>
           <a:xfrm>
-            <a:off x="603504" y="4937760"/>
+            <a:off x="603504" y="5053578"/>
             <a:ext cx="6675120" cy="256032"/>
           </a:xfrm>
           <a:prstGeom prst="rect">
@@ -6215,7 +6155,7 @@
         </p:nvSpPr>
         <p:spPr>
           <a:xfrm>
-            <a:off x="566928" y="5399532"/>
+            <a:off x="566928" y="5515350"/>
             <a:ext cx="69850" cy="69850"/>
           </a:xfrm>
           <a:prstGeom prst="ellipse">
@@ -6259,7 +6199,7 @@
         </p:nvSpPr>
         <p:spPr>
           <a:xfrm>
-            <a:off x="749808" y="5349240"/>
+            <a:off x="749808" y="5465058"/>
             <a:ext cx="6583680" cy="365760"/>
           </a:xfrm>
           <a:prstGeom prst="rect">
@@ -6282,7 +6222,7 @@
               </a:spcAft>
             </a:pPr>
             <a:r>
-              <a:rPr sz="1050" b="0">
+              <a:rPr sz="1000" b="0">
                 <a:solidFill>
                   <a:srgbClr val="444C57"/>
                 </a:solidFill>
@@ -6301,7 +6241,7 @@
         </p:nvSpPr>
         <p:spPr>
           <a:xfrm>
-            <a:off x="566928" y="5838444"/>
+            <a:off x="566928" y="5973565"/>
             <a:ext cx="69850" cy="69850"/>
           </a:xfrm>
           <a:prstGeom prst="ellipse">
@@ -6345,7 +6285,7 @@
         </p:nvSpPr>
         <p:spPr>
           <a:xfrm>
-            <a:off x="749808" y="5788152"/>
+            <a:off x="749808" y="5923273"/>
             <a:ext cx="6583680" cy="365760"/>
           </a:xfrm>
           <a:prstGeom prst="rect">
@@ -6368,7 +6308,7 @@
               </a:spcAft>
             </a:pPr>
             <a:r>
-              <a:rPr sz="1050" b="0">
+              <a:rPr sz="1000" b="0">
                 <a:solidFill>
                   <a:srgbClr val="444C57"/>
                 </a:solidFill>
@@ -6387,7 +6327,7 @@
         </p:nvSpPr>
         <p:spPr>
           <a:xfrm>
-            <a:off x="566928" y="6103620"/>
+            <a:off x="566928" y="6289541"/>
             <a:ext cx="69850" cy="69850"/>
           </a:xfrm>
           <a:prstGeom prst="ellipse">
@@ -6431,7 +6371,7 @@
         </p:nvSpPr>
         <p:spPr>
           <a:xfrm>
-            <a:off x="749808" y="6053328"/>
+            <a:off x="749808" y="6239249"/>
             <a:ext cx="6583680" cy="365760"/>
           </a:xfrm>
           <a:prstGeom prst="rect">
@@ -6454,7 +6394,7 @@
               </a:spcAft>
             </a:pPr>
             <a:r>
-              <a:rPr sz="1050" b="0">
+              <a:rPr sz="1000" b="0">
                 <a:solidFill>
                   <a:srgbClr val="444C57"/>
                 </a:solidFill>
@@ -7766,16 +7706,6 @@
               </a:rPr>
               <a:t>· </a:t>
             </a:r>
-          </a:p>
-          <a:p>
-            <a:pPr algn="l">
-              <a:lnSpc>
-                <a:spcPct val="108000"/>
-              </a:lnSpc>
-              <a:spcAft>
-                <a:spcPts val="300"/>
-              </a:spcAft>
-            </a:pPr>
             <a:r>
               <a:rPr sz="950" b="0">
                 <a:solidFill>
@@ -7827,16 +7757,6 @@
               </a:rPr>
               <a:t>· </a:t>
             </a:r>
-          </a:p>
-          <a:p>
-            <a:pPr algn="l">
-              <a:lnSpc>
-                <a:spcPct val="108000"/>
-              </a:lnSpc>
-              <a:spcAft>
-                <a:spcPts val="300"/>
-              </a:spcAft>
-            </a:pPr>
             <a:r>
               <a:rPr sz="950" b="0">
                 <a:solidFill>
@@ -7888,16 +7808,6 @@
               </a:rPr>
               <a:t>· </a:t>
             </a:r>
-          </a:p>
-          <a:p>
-            <a:pPr algn="l">
-              <a:lnSpc>
-                <a:spcPct val="108000"/>
-              </a:lnSpc>
-              <a:spcAft>
-                <a:spcPts val="300"/>
-              </a:spcAft>
-            </a:pPr>
             <a:r>
               <a:rPr sz="950" b="0">
                 <a:solidFill>
@@ -7949,16 +7859,6 @@
               </a:rPr>
               <a:t>· </a:t>
             </a:r>
-          </a:p>
-          <a:p>
-            <a:pPr algn="l">
-              <a:lnSpc>
-                <a:spcPct val="108000"/>
-              </a:lnSpc>
-              <a:spcAft>
-                <a:spcPts val="300"/>
-              </a:spcAft>
-            </a:pPr>
             <a:r>
               <a:rPr sz="950" b="0">
                 <a:solidFill>
@@ -8010,16 +7910,6 @@
               </a:rPr>
               <a:t>· </a:t>
             </a:r>
-          </a:p>
-          <a:p>
-            <a:pPr algn="l">
-              <a:lnSpc>
-                <a:spcPct val="108000"/>
-              </a:lnSpc>
-              <a:spcAft>
-                <a:spcPts val="300"/>
-              </a:spcAft>
-            </a:pPr>
             <a:r>
               <a:rPr sz="950" b="0">
                 <a:solidFill>
@@ -8203,16 +8093,6 @@
               </a:rPr>
               <a:t>· </a:t>
             </a:r>
-          </a:p>
-          <a:p>
-            <a:pPr algn="l">
-              <a:lnSpc>
-                <a:spcPct val="108000"/>
-              </a:lnSpc>
-              <a:spcAft>
-                <a:spcPts val="300"/>
-              </a:spcAft>
-            </a:pPr>
             <a:r>
               <a:rPr sz="950" b="0">
                 <a:solidFill>
@@ -8264,16 +8144,6 @@
               </a:rPr>
               <a:t>· </a:t>
             </a:r>
-          </a:p>
-          <a:p>
-            <a:pPr algn="l">
-              <a:lnSpc>
-                <a:spcPct val="108000"/>
-              </a:lnSpc>
-              <a:spcAft>
-                <a:spcPts val="300"/>
-              </a:spcAft>
-            </a:pPr>
             <a:r>
               <a:rPr sz="950" b="0">
                 <a:solidFill>
@@ -8325,16 +8195,6 @@
               </a:rPr>
               <a:t>· </a:t>
             </a:r>
-          </a:p>
-          <a:p>
-            <a:pPr algn="l">
-              <a:lnSpc>
-                <a:spcPct val="108000"/>
-              </a:lnSpc>
-              <a:spcAft>
-                <a:spcPts val="300"/>
-              </a:spcAft>
-            </a:pPr>
             <a:r>
               <a:rPr sz="950" b="0">
                 <a:solidFill>
@@ -8386,16 +8246,6 @@
               </a:rPr>
               <a:t>· </a:t>
             </a:r>
-          </a:p>
-          <a:p>
-            <a:pPr algn="l">
-              <a:lnSpc>
-                <a:spcPct val="108000"/>
-              </a:lnSpc>
-              <a:spcAft>
-                <a:spcPts val="300"/>
-              </a:spcAft>
-            </a:pPr>
             <a:r>
               <a:rPr sz="950" b="0">
                 <a:solidFill>
@@ -8447,16 +8297,6 @@
               </a:rPr>
               <a:t>· </a:t>
             </a:r>
-          </a:p>
-          <a:p>
-            <a:pPr algn="l">
-              <a:lnSpc>
-                <a:spcPct val="108000"/>
-              </a:lnSpc>
-              <a:spcAft>
-                <a:spcPts val="300"/>
-              </a:spcAft>
-            </a:pPr>
             <a:r>
               <a:rPr sz="950" b="0">
                 <a:solidFill>
@@ -8640,16 +8480,6 @@
               </a:rPr>
               <a:t>· </a:t>
             </a:r>
-          </a:p>
-          <a:p>
-            <a:pPr algn="l">
-              <a:lnSpc>
-                <a:spcPct val="108000"/>
-              </a:lnSpc>
-              <a:spcAft>
-                <a:spcPts val="300"/>
-              </a:spcAft>
-            </a:pPr>
             <a:r>
               <a:rPr sz="950" b="0">
                 <a:solidFill>
@@ -8701,16 +8531,6 @@
               </a:rPr>
               <a:t>· </a:t>
             </a:r>
-          </a:p>
-          <a:p>
-            <a:pPr algn="l">
-              <a:lnSpc>
-                <a:spcPct val="108000"/>
-              </a:lnSpc>
-              <a:spcAft>
-                <a:spcPts val="300"/>
-              </a:spcAft>
-            </a:pPr>
             <a:r>
               <a:rPr sz="950" b="0">
                 <a:solidFill>
@@ -8762,16 +8582,6 @@
               </a:rPr>
               <a:t>· </a:t>
             </a:r>
-          </a:p>
-          <a:p>
-            <a:pPr algn="l">
-              <a:lnSpc>
-                <a:spcPct val="108000"/>
-              </a:lnSpc>
-              <a:spcAft>
-                <a:spcPts val="300"/>
-              </a:spcAft>
-            </a:pPr>
             <a:r>
               <a:rPr sz="950" b="0">
                 <a:solidFill>
@@ -8823,16 +8633,6 @@
               </a:rPr>
               <a:t>· </a:t>
             </a:r>
-          </a:p>
-          <a:p>
-            <a:pPr algn="l">
-              <a:lnSpc>
-                <a:spcPct val="108000"/>
-              </a:lnSpc>
-              <a:spcAft>
-                <a:spcPts val="300"/>
-              </a:spcAft>
-            </a:pPr>
             <a:r>
               <a:rPr sz="950" b="0">
                 <a:solidFill>
@@ -8884,16 +8684,6 @@
               </a:rPr>
               <a:t>· </a:t>
             </a:r>
-          </a:p>
-          <a:p>
-            <a:pPr algn="l">
-              <a:lnSpc>
-                <a:spcPct val="108000"/>
-              </a:lnSpc>
-              <a:spcAft>
-                <a:spcPts val="300"/>
-              </a:spcAft>
-            </a:pPr>
             <a:r>
               <a:rPr sz="950" b="0">
                 <a:solidFill>
@@ -9077,16 +8867,6 @@
               </a:rPr>
               <a:t>· </a:t>
             </a:r>
-          </a:p>
-          <a:p>
-            <a:pPr algn="l">
-              <a:lnSpc>
-                <a:spcPct val="108000"/>
-              </a:lnSpc>
-              <a:spcAft>
-                <a:spcPts val="300"/>
-              </a:spcAft>
-            </a:pPr>
             <a:r>
               <a:rPr sz="950" b="0">
                 <a:solidFill>
@@ -9138,16 +8918,6 @@
               </a:rPr>
               <a:t>· </a:t>
             </a:r>
-          </a:p>
-          <a:p>
-            <a:pPr algn="l">
-              <a:lnSpc>
-                <a:spcPct val="108000"/>
-              </a:lnSpc>
-              <a:spcAft>
-                <a:spcPts val="300"/>
-              </a:spcAft>
-            </a:pPr>
             <a:r>
               <a:rPr sz="950" b="0">
                 <a:solidFill>
@@ -9199,16 +8969,6 @@
               </a:rPr>
               <a:t>· </a:t>
             </a:r>
-          </a:p>
-          <a:p>
-            <a:pPr algn="l">
-              <a:lnSpc>
-                <a:spcPct val="108000"/>
-              </a:lnSpc>
-              <a:spcAft>
-                <a:spcPts val="300"/>
-              </a:spcAft>
-            </a:pPr>
             <a:r>
               <a:rPr sz="950" b="0">
                 <a:solidFill>
@@ -9260,16 +9020,6 @@
               </a:rPr>
               <a:t>· </a:t>
             </a:r>
-          </a:p>
-          <a:p>
-            <a:pPr algn="l">
-              <a:lnSpc>
-                <a:spcPct val="108000"/>
-              </a:lnSpc>
-              <a:spcAft>
-                <a:spcPts val="300"/>
-              </a:spcAft>
-            </a:pPr>
             <a:r>
               <a:rPr sz="950" b="0">
                 <a:solidFill>
@@ -9321,16 +9071,6 @@
               </a:rPr>
               <a:t>· </a:t>
             </a:r>
-          </a:p>
-          <a:p>
-            <a:pPr algn="l">
-              <a:lnSpc>
-                <a:spcPct val="108000"/>
-              </a:lnSpc>
-              <a:spcAft>
-                <a:spcPts val="300"/>
-              </a:spcAft>
-            </a:pPr>
             <a:r>
               <a:rPr sz="950" b="0">
                 <a:solidFill>
@@ -11669,16 +11409,6 @@
               </a:rPr>
               <a:t>Worked example: "Sonar transducer showing abnormal vibration and casing fracture" → </a:t>
             </a:r>
-          </a:p>
-          <a:p>
-            <a:pPr algn="l">
-              <a:lnSpc>
-                <a:spcPct val="120000"/>
-              </a:lnSpc>
-              <a:spcAft>
-                <a:spcPts val="300"/>
-              </a:spcAft>
-            </a:pPr>
             <a:r>
               <a:rPr sz="1050" b="1">
                 <a:solidFill>
@@ -14468,7 +14198,7 @@
         <p:spPr>
           <a:xfrm>
             <a:off x="457200" y="1527048"/>
-            <a:ext cx="3611880" cy="1691640"/>
+            <a:ext cx="3611880" cy="1755648"/>
           </a:xfrm>
           <a:prstGeom prst="rect">
             <a:avLst/>
@@ -14599,8 +14329,8 @@
         </p:nvSpPr>
         <p:spPr>
           <a:xfrm>
-            <a:off x="603504" y="1965960"/>
-            <a:ext cx="3337560" cy="384048"/>
+            <a:off x="603504" y="1947672"/>
+            <a:ext cx="3291840" cy="402336"/>
           </a:xfrm>
           <a:prstGeom prst="rect">
             <a:avLst/>
@@ -14622,7 +14352,7 @@
               </a:spcAft>
             </a:pPr>
             <a:r>
-              <a:rPr sz="1000" b="1">
+              <a:rPr sz="950" b="1">
                 <a:solidFill>
                   <a:srgbClr val="1E6FBA"/>
                 </a:solidFill>
@@ -14630,7 +14360,39 @@
               </a:rPr>
               <a:t>· </a:t>
             </a:r>
-          </a:p>
+            <a:r>
+              <a:rPr sz="950" b="0">
+                <a:solidFill>
+                  <a:srgbClr val="444C57"/>
+                </a:solidFill>
+                <a:latin typeface="Calibri"/>
+              </a:rPr>
+              <a:t>Learn, test and certify with zero connectivity — at sea and at remote sites</a:t>
+            </a:r>
+          </a:p>
+        </p:txBody>
+      </p:sp>
+      <p:sp>
+        <p:nvSpPr>
+          <p:cNvPr id="18" name="TextBox 17"/>
+          <p:cNvSpPr txBox="1"/>
+          <p:nvPr/>
+        </p:nvSpPr>
+        <p:spPr>
+          <a:xfrm>
+            <a:off x="603504" y="2377440"/>
+            <a:ext cx="3291840" cy="402336"/>
+          </a:xfrm>
+          <a:prstGeom prst="rect">
+            <a:avLst/>
+          </a:prstGeom>
+          <a:noFill/>
+        </p:spPr>
+        <p:txBody>
+          <a:bodyPr wrap="square" lIns="0" rIns="0" tIns="0" bIns="0" anchor="t">
+            <a:spAutoFit/>
+          </a:bodyPr>
+          <a:lstStyle/>
           <a:p>
             <a:pPr algn="l">
               <a:lnSpc>
@@ -14641,27 +14403,36 @@
               </a:spcAft>
             </a:pPr>
             <a:r>
+              <a:rPr sz="950" b="1">
+                <a:solidFill>
+                  <a:srgbClr val="1E6FBA"/>
+                </a:solidFill>
+                <a:latin typeface="Calibri"/>
+              </a:rPr>
+              <a:t>· </a:t>
+            </a:r>
+            <a:r>
               <a:rPr sz="950" b="0">
                 <a:solidFill>
                   <a:srgbClr val="444C57"/>
                 </a:solidFill>
                 <a:latin typeface="Calibri"/>
               </a:rPr>
-              <a:t>Learn, test and get certified with zero connectivity — at sea, at buoy sites, in observatories</a:t>
-            </a:r>
-          </a:p>
-        </p:txBody>
-      </p:sp>
-      <p:sp>
-        <p:nvSpPr>
-          <p:cNvPr id="18" name="TextBox 17"/>
-          <p:cNvSpPr txBox="1"/>
-          <p:nvPr/>
-        </p:nvSpPr>
-        <p:spPr>
-          <a:xfrm>
-            <a:off x="603504" y="2368296"/>
-            <a:ext cx="3337560" cy="384048"/>
+              <a:t>Guided AI diagnostics instead of waiting for shore support</a:t>
+            </a:r>
+          </a:p>
+        </p:txBody>
+      </p:sp>
+      <p:sp>
+        <p:nvSpPr>
+          <p:cNvPr id="19" name="TextBox 18"/>
+          <p:cNvSpPr txBox="1"/>
+          <p:nvPr/>
+        </p:nvSpPr>
+        <p:spPr>
+          <a:xfrm>
+            <a:off x="603504" y="2807208"/>
+            <a:ext cx="3291840" cy="402336"/>
           </a:xfrm>
           <a:prstGeom prst="rect">
             <a:avLst/>
@@ -14683,7 +14454,7 @@
               </a:spcAft>
             </a:pPr>
             <a:r>
-              <a:rPr sz="1000" b="1">
+              <a:rPr sz="950" b="1">
                 <a:solidFill>
                   <a:srgbClr val="1E6FBA"/>
                 </a:solidFill>
@@ -14691,77 +14462,6 @@
               </a:rPr>
               <a:t>· </a:t>
             </a:r>
-          </a:p>
-          <a:p>
-            <a:pPr algn="l">
-              <a:lnSpc>
-                <a:spcPct val="110000"/>
-              </a:lnSpc>
-              <a:spcAft>
-                <a:spcPts val="300"/>
-              </a:spcAft>
-            </a:pPr>
-            <a:r>
-              <a:rPr sz="950" b="0">
-                <a:solidFill>
-                  <a:srgbClr val="444C57"/>
-                </a:solidFill>
-                <a:latin typeface="Calibri"/>
-              </a:rPr>
-              <a:t>Guided AI diagnostics instead of waiting for shore support</a:t>
-            </a:r>
-          </a:p>
-        </p:txBody>
-      </p:sp>
-      <p:sp>
-        <p:nvSpPr>
-          <p:cNvPr id="19" name="TextBox 18"/>
-          <p:cNvSpPr txBox="1"/>
-          <p:nvPr/>
-        </p:nvSpPr>
-        <p:spPr>
-          <a:xfrm>
-            <a:off x="603504" y="2770632"/>
-            <a:ext cx="3337560" cy="384048"/>
-          </a:xfrm>
-          <a:prstGeom prst="rect">
-            <a:avLst/>
-          </a:prstGeom>
-          <a:noFill/>
-        </p:spPr>
-        <p:txBody>
-          <a:bodyPr wrap="square" lIns="0" rIns="0" tIns="0" bIns="0" anchor="t">
-            <a:spAutoFit/>
-          </a:bodyPr>
-          <a:lstStyle/>
-          <a:p>
-            <a:pPr algn="l">
-              <a:lnSpc>
-                <a:spcPct val="110000"/>
-              </a:lnSpc>
-              <a:spcAft>
-                <a:spcPts val="300"/>
-              </a:spcAft>
-            </a:pPr>
-            <a:r>
-              <a:rPr sz="1000" b="1">
-                <a:solidFill>
-                  <a:srgbClr val="1E6FBA"/>
-                </a:solidFill>
-                <a:latin typeface="Calibri"/>
-              </a:rPr>
-              <a:t>· </a:t>
-            </a:r>
-          </a:p>
-          <a:p>
-            <a:pPr algn="l">
-              <a:lnSpc>
-                <a:spcPct val="110000"/>
-              </a:lnSpc>
-              <a:spcAft>
-                <a:spcPts val="300"/>
-              </a:spcAft>
-            </a:pPr>
             <a:r>
               <a:rPr sz="950" b="0">
                 <a:solidFill>
@@ -14783,7 +14483,7 @@
         <p:spPr>
           <a:xfrm>
             <a:off x="4251960" y="1527048"/>
-            <a:ext cx="3611880" cy="1691640"/>
+            <a:ext cx="3611880" cy="1755648"/>
           </a:xfrm>
           <a:prstGeom prst="rect">
             <a:avLst/>
@@ -14914,8 +14614,8 @@
         </p:nvSpPr>
         <p:spPr>
           <a:xfrm>
-            <a:off x="4398264" y="1965960"/>
-            <a:ext cx="3337560" cy="384048"/>
+            <a:off x="4398264" y="1947672"/>
+            <a:ext cx="3291840" cy="402336"/>
           </a:xfrm>
           <a:prstGeom prst="rect">
             <a:avLst/>
@@ -14937,7 +14637,7 @@
               </a:spcAft>
             </a:pPr>
             <a:r>
-              <a:rPr sz="1000" b="1">
+              <a:rPr sz="950" b="1">
                 <a:solidFill>
                   <a:srgbClr val="F27C1E"/>
                 </a:solidFill>
@@ -14945,7 +14645,39 @@
               </a:rPr>
               <a:t>· </a:t>
             </a:r>
-          </a:p>
+            <a:r>
+              <a:rPr sz="950" b="0">
+                <a:solidFill>
+                  <a:srgbClr val="444C57"/>
+                </a:solidFill>
+                <a:latin typeface="Calibri"/>
+              </a:rPr>
+              <a:t>One versioned library for lectures, presentations and material</a:t>
+            </a:r>
+          </a:p>
+        </p:txBody>
+      </p:sp>
+      <p:sp>
+        <p:nvSpPr>
+          <p:cNvPr id="24" name="TextBox 23"/>
+          <p:cNvSpPr txBox="1"/>
+          <p:nvPr/>
+        </p:nvSpPr>
+        <p:spPr>
+          <a:xfrm>
+            <a:off x="4398264" y="2377440"/>
+            <a:ext cx="3291840" cy="402336"/>
+          </a:xfrm>
+          <a:prstGeom prst="rect">
+            <a:avLst/>
+          </a:prstGeom>
+          <a:noFill/>
+        </p:spPr>
+        <p:txBody>
+          <a:bodyPr wrap="square" lIns="0" rIns="0" tIns="0" bIns="0" anchor="t">
+            <a:spAutoFit/>
+          </a:bodyPr>
+          <a:lstStyle/>
           <a:p>
             <a:pPr algn="l">
               <a:lnSpc>
@@ -14956,27 +14688,36 @@
               </a:spcAft>
             </a:pPr>
             <a:r>
+              <a:rPr sz="950" b="1">
+                <a:solidFill>
+                  <a:srgbClr val="F27C1E"/>
+                </a:solidFill>
+                <a:latin typeface="Calibri"/>
+              </a:rPr>
+              <a:t>· </a:t>
+            </a:r>
+            <a:r>
               <a:rPr sz="950" b="0">
                 <a:solidFill>
                   <a:srgbClr val="444C57"/>
                 </a:solidFill>
                 <a:latin typeface="Calibri"/>
               </a:rPr>
-              <a:t>One versioned library for lectures, presentations and material</a:t>
-            </a:r>
-          </a:p>
-        </p:txBody>
-      </p:sp>
-      <p:sp>
-        <p:nvSpPr>
-          <p:cNvPr id="24" name="TextBox 23"/>
-          <p:cNvSpPr txBox="1"/>
-          <p:nvPr/>
-        </p:nvSpPr>
-        <p:spPr>
-          <a:xfrm>
-            <a:off x="4398264" y="2368296"/>
-            <a:ext cx="3337560" cy="384048"/>
+              <a:t>Questionnaires with deadlines, auto-scoring, live participation view</a:t>
+            </a:r>
+          </a:p>
+        </p:txBody>
+      </p:sp>
+      <p:sp>
+        <p:nvSpPr>
+          <p:cNvPr id="25" name="TextBox 24"/>
+          <p:cNvSpPr txBox="1"/>
+          <p:nvPr/>
+        </p:nvSpPr>
+        <p:spPr>
+          <a:xfrm>
+            <a:off x="4398264" y="2807208"/>
+            <a:ext cx="3291840" cy="402336"/>
           </a:xfrm>
           <a:prstGeom prst="rect">
             <a:avLst/>
@@ -14998,7 +14739,7 @@
               </a:spcAft>
             </a:pPr>
             <a:r>
-              <a:rPr sz="1000" b="1">
+              <a:rPr sz="950" b="1">
                 <a:solidFill>
                   <a:srgbClr val="F27C1E"/>
                 </a:solidFill>
@@ -15006,77 +14747,6 @@
               </a:rPr>
               <a:t>· </a:t>
             </a:r>
-          </a:p>
-          <a:p>
-            <a:pPr algn="l">
-              <a:lnSpc>
-                <a:spcPct val="110000"/>
-              </a:lnSpc>
-              <a:spcAft>
-                <a:spcPts val="300"/>
-              </a:spcAft>
-            </a:pPr>
-            <a:r>
-              <a:rPr sz="950" b="0">
-                <a:solidFill>
-                  <a:srgbClr val="444C57"/>
-                </a:solidFill>
-                <a:latin typeface="Calibri"/>
-              </a:rPr>
-              <a:t>Questionnaires with deadlines, auto-scoring, live participation view</a:t>
-            </a:r>
-          </a:p>
-        </p:txBody>
-      </p:sp>
-      <p:sp>
-        <p:nvSpPr>
-          <p:cNvPr id="25" name="TextBox 24"/>
-          <p:cNvSpPr txBox="1"/>
-          <p:nvPr/>
-        </p:nvSpPr>
-        <p:spPr>
-          <a:xfrm>
-            <a:off x="4398264" y="2770632"/>
-            <a:ext cx="3337560" cy="384048"/>
-          </a:xfrm>
-          <a:prstGeom prst="rect">
-            <a:avLst/>
-          </a:prstGeom>
-          <a:noFill/>
-        </p:spPr>
-        <p:txBody>
-          <a:bodyPr wrap="square" lIns="0" rIns="0" tIns="0" bIns="0" anchor="t">
-            <a:spAutoFit/>
-          </a:bodyPr>
-          <a:lstStyle/>
-          <a:p>
-            <a:pPr algn="l">
-              <a:lnSpc>
-                <a:spcPct val="110000"/>
-              </a:lnSpc>
-              <a:spcAft>
-                <a:spcPts val="300"/>
-              </a:spcAft>
-            </a:pPr>
-            <a:r>
-              <a:rPr sz="1000" b="1">
-                <a:solidFill>
-                  <a:srgbClr val="F27C1E"/>
-                </a:solidFill>
-                <a:latin typeface="Calibri"/>
-              </a:rPr>
-              <a:t>· </a:t>
-            </a:r>
-          </a:p>
-          <a:p>
-            <a:pPr algn="l">
-              <a:lnSpc>
-                <a:spcPct val="110000"/>
-              </a:lnSpc>
-              <a:spcAft>
-                <a:spcPts val="300"/>
-              </a:spcAft>
-            </a:pPr>
             <a:r>
               <a:rPr sz="950" b="0">
                 <a:solidFill>
@@ -15098,7 +14768,7 @@
         <p:spPr>
           <a:xfrm>
             <a:off x="8046720" y="1527048"/>
-            <a:ext cx="3611880" cy="1691640"/>
+            <a:ext cx="3611880" cy="1755648"/>
           </a:xfrm>
           <a:prstGeom prst="rect">
             <a:avLst/>
@@ -15229,8 +14899,8 @@
         </p:nvSpPr>
         <p:spPr>
           <a:xfrm>
-            <a:off x="8193024" y="1965960"/>
-            <a:ext cx="3337560" cy="384048"/>
+            <a:off x="8193024" y="1947672"/>
+            <a:ext cx="3291840" cy="402336"/>
           </a:xfrm>
           <a:prstGeom prst="rect">
             <a:avLst/>
@@ -15252,7 +14922,7 @@
               </a:spcAft>
             </a:pPr>
             <a:r>
-              <a:rPr sz="1000" b="1">
+              <a:rPr sz="950" b="1">
                 <a:solidFill>
                   <a:srgbClr val="2E8B57"/>
                 </a:solidFill>
@@ -15260,7 +14930,39 @@
               </a:rPr>
               <a:t>· </a:t>
             </a:r>
-          </a:p>
+            <a:r>
+              <a:rPr sz="950" b="0">
+                <a:solidFill>
+                  <a:srgbClr val="444C57"/>
+                </a:solidFill>
+                <a:latin typeface="Calibri"/>
+              </a:rPr>
+              <a:t>Live dashboards of enrollment, certification and assessment</a:t>
+            </a:r>
+          </a:p>
+        </p:txBody>
+      </p:sp>
+      <p:sp>
+        <p:nvSpPr>
+          <p:cNvPr id="30" name="TextBox 29"/>
+          <p:cNvSpPr txBox="1"/>
+          <p:nvPr/>
+        </p:nvSpPr>
+        <p:spPr>
+          <a:xfrm>
+            <a:off x="8193024" y="2377440"/>
+            <a:ext cx="3291840" cy="402336"/>
+          </a:xfrm>
+          <a:prstGeom prst="rect">
+            <a:avLst/>
+          </a:prstGeom>
+          <a:noFill/>
+        </p:spPr>
+        <p:txBody>
+          <a:bodyPr wrap="square" lIns="0" rIns="0" tIns="0" bIns="0" anchor="t">
+            <a:spAutoFit/>
+          </a:bodyPr>
+          <a:lstStyle/>
           <a:p>
             <a:pPr algn="l">
               <a:lnSpc>
@@ -15271,27 +14973,36 @@
               </a:spcAft>
             </a:pPr>
             <a:r>
+              <a:rPr sz="950" b="1">
+                <a:solidFill>
+                  <a:srgbClr val="2E8B57"/>
+                </a:solidFill>
+                <a:latin typeface="Calibri"/>
+              </a:rPr>
+              <a:t>· </a:t>
+            </a:r>
+            <a:r>
               <a:rPr sz="950" b="0">
                 <a:solidFill>
                   <a:srgbClr val="444C57"/>
                 </a:solidFill>
                 <a:latin typeface="Calibri"/>
               </a:rPr>
-              <a:t>Live dashboards of enrollment, certification and assessment</a:t>
-            </a:r>
-          </a:p>
-        </p:txBody>
-      </p:sp>
-      <p:sp>
-        <p:nvSpPr>
-          <p:cNvPr id="30" name="TextBox 29"/>
-          <p:cNvSpPr txBox="1"/>
-          <p:nvPr/>
-        </p:nvSpPr>
-        <p:spPr>
-          <a:xfrm>
-            <a:off x="8193024" y="2368296"/>
-            <a:ext cx="3337560" cy="384048"/>
+              <a:t>Objective trainer selection via competency mapping</a:t>
+            </a:r>
+          </a:p>
+        </p:txBody>
+      </p:sp>
+      <p:sp>
+        <p:nvSpPr>
+          <p:cNvPr id="31" name="TextBox 30"/>
+          <p:cNvSpPr txBox="1"/>
+          <p:nvPr/>
+        </p:nvSpPr>
+        <p:spPr>
+          <a:xfrm>
+            <a:off x="8193024" y="2807208"/>
+            <a:ext cx="3291840" cy="402336"/>
           </a:xfrm>
           <a:prstGeom prst="rect">
             <a:avLst/>
@@ -15313,7 +15024,7 @@
               </a:spcAft>
             </a:pPr>
             <a:r>
-              <a:rPr sz="1000" b="1">
+              <a:rPr sz="950" b="1">
                 <a:solidFill>
                   <a:srgbClr val="2E8B57"/>
                 </a:solidFill>
@@ -15321,77 +15032,6 @@
               </a:rPr>
               <a:t>· </a:t>
             </a:r>
-          </a:p>
-          <a:p>
-            <a:pPr algn="l">
-              <a:lnSpc>
-                <a:spcPct val="110000"/>
-              </a:lnSpc>
-              <a:spcAft>
-                <a:spcPts val="300"/>
-              </a:spcAft>
-            </a:pPr>
-            <a:r>
-              <a:rPr sz="950" b="0">
-                <a:solidFill>
-                  <a:srgbClr val="444C57"/>
-                </a:solidFill>
-                <a:latin typeface="Calibri"/>
-              </a:rPr>
-              <a:t>Objective trainer selection via competency mapping</a:t>
-            </a:r>
-          </a:p>
-        </p:txBody>
-      </p:sp>
-      <p:sp>
-        <p:nvSpPr>
-          <p:cNvPr id="31" name="TextBox 30"/>
-          <p:cNvSpPr txBox="1"/>
-          <p:nvPr/>
-        </p:nvSpPr>
-        <p:spPr>
-          <a:xfrm>
-            <a:off x="8193024" y="2770632"/>
-            <a:ext cx="3337560" cy="384048"/>
-          </a:xfrm>
-          <a:prstGeom prst="rect">
-            <a:avLst/>
-          </a:prstGeom>
-          <a:noFill/>
-        </p:spPr>
-        <p:txBody>
-          <a:bodyPr wrap="square" lIns="0" rIns="0" tIns="0" bIns="0" anchor="t">
-            <a:spAutoFit/>
-          </a:bodyPr>
-          <a:lstStyle/>
-          <a:p>
-            <a:pPr algn="l">
-              <a:lnSpc>
-                <a:spcPct val="110000"/>
-              </a:lnSpc>
-              <a:spcAft>
-                <a:spcPts val="300"/>
-              </a:spcAft>
-            </a:pPr>
-            <a:r>
-              <a:rPr sz="1000" b="1">
-                <a:solidFill>
-                  <a:srgbClr val="2E8B57"/>
-                </a:solidFill>
-                <a:latin typeface="Calibri"/>
-              </a:rPr>
-              <a:t>· </a:t>
-            </a:r>
-          </a:p>
-          <a:p>
-            <a:pPr algn="l">
-              <a:lnSpc>
-                <a:spcPct val="110000"/>
-              </a:lnSpc>
-              <a:spcAft>
-                <a:spcPts val="300"/>
-              </a:spcAft>
-            </a:pPr>
             <a:r>
               <a:rPr sz="950" b="0">
                 <a:solidFill>
@@ -15412,7 +15052,7 @@
         </p:nvSpPr>
         <p:spPr>
           <a:xfrm>
-            <a:off x="457200" y="3429000"/>
+            <a:off x="457200" y="3483864"/>
             <a:ext cx="11292840" cy="347472"/>
           </a:xfrm>
           <a:prstGeom prst="roundRect">
@@ -15458,7 +15098,7 @@
         </p:nvSpPr>
         <p:spPr>
           <a:xfrm>
-            <a:off x="603504" y="3493008"/>
+            <a:off x="603504" y="3547872"/>
             <a:ext cx="11018520" cy="256032"/>
           </a:xfrm>
           <a:prstGeom prst="rect">
@@ -15500,7 +15140,7 @@
         </p:nvSpPr>
         <p:spPr>
           <a:xfrm>
-            <a:off x="457200" y="3904488"/>
+            <a:off x="457200" y="3959352"/>
             <a:ext cx="3611880" cy="1234440"/>
           </a:xfrm>
           <a:prstGeom prst="rect">
@@ -15546,7 +15186,7 @@
         </p:nvSpPr>
         <p:spPr>
           <a:xfrm>
-            <a:off x="457200" y="3904488"/>
+            <a:off x="457200" y="3959352"/>
             <a:ext cx="50800" cy="1234440"/>
           </a:xfrm>
           <a:prstGeom prst="rect">
@@ -15590,7 +15230,7 @@
         </p:nvSpPr>
         <p:spPr>
           <a:xfrm>
-            <a:off x="621792" y="4014216"/>
+            <a:off x="621792" y="4069080"/>
             <a:ext cx="3291840" cy="228600"/>
           </a:xfrm>
           <a:prstGeom prst="rect">
@@ -15632,7 +15272,7 @@
         </p:nvSpPr>
         <p:spPr>
           <a:xfrm>
-            <a:off x="621792" y="4288536"/>
+            <a:off x="621792" y="4343400"/>
             <a:ext cx="3291840" cy="777240"/>
           </a:xfrm>
           <a:prstGeom prst="rect">
@@ -15674,7 +15314,7 @@
         </p:nvSpPr>
         <p:spPr>
           <a:xfrm>
-            <a:off x="4251960" y="3904488"/>
+            <a:off x="4251960" y="3959352"/>
             <a:ext cx="3611880" cy="1234440"/>
           </a:xfrm>
           <a:prstGeom prst="rect">
@@ -15720,7 +15360,7 @@
         </p:nvSpPr>
         <p:spPr>
           <a:xfrm>
-            <a:off x="4251960" y="3904488"/>
+            <a:off x="4251960" y="3959352"/>
             <a:ext cx="50800" cy="1234440"/>
           </a:xfrm>
           <a:prstGeom prst="rect">
@@ -15764,7 +15404,7 @@
         </p:nvSpPr>
         <p:spPr>
           <a:xfrm>
-            <a:off x="4416552" y="4014216"/>
+            <a:off x="4416552" y="4069080"/>
             <a:ext cx="3291840" cy="228600"/>
           </a:xfrm>
           <a:prstGeom prst="rect">
@@ -15806,7 +15446,7 @@
         </p:nvSpPr>
         <p:spPr>
           <a:xfrm>
-            <a:off x="4416552" y="4288536"/>
+            <a:off x="4416552" y="4343400"/>
             <a:ext cx="3291840" cy="777240"/>
           </a:xfrm>
           <a:prstGeom prst="rect">
@@ -15848,7 +15488,7 @@
         </p:nvSpPr>
         <p:spPr>
           <a:xfrm>
-            <a:off x="8046720" y="3904488"/>
+            <a:off x="8046720" y="3959352"/>
             <a:ext cx="3611880" cy="1234440"/>
           </a:xfrm>
           <a:prstGeom prst="rect">
@@ -15894,7 +15534,7 @@
         </p:nvSpPr>
         <p:spPr>
           <a:xfrm>
-            <a:off x="8046720" y="3904488"/>
+            <a:off x="8046720" y="3959352"/>
             <a:ext cx="50800" cy="1234440"/>
           </a:xfrm>
           <a:prstGeom prst="rect">
@@ -15938,7 +15578,7 @@
         </p:nvSpPr>
         <p:spPr>
           <a:xfrm>
-            <a:off x="8211312" y="4014216"/>
+            <a:off x="8211312" y="4069080"/>
             <a:ext cx="3291840" cy="228600"/>
           </a:xfrm>
           <a:prstGeom prst="rect">
@@ -15980,7 +15620,7 @@
         </p:nvSpPr>
         <p:spPr>
           <a:xfrm>
-            <a:off x="8211312" y="4288536"/>
+            <a:off x="8211312" y="4343400"/>
             <a:ext cx="3291840" cy="777240"/>
           </a:xfrm>
           <a:prstGeom prst="rect">
@@ -16022,7 +15662,7 @@
         </p:nvSpPr>
         <p:spPr>
           <a:xfrm>
-            <a:off x="457200" y="5321808"/>
+            <a:off x="457200" y="5376672"/>
             <a:ext cx="11292840" cy="566928"/>
           </a:xfrm>
           <a:prstGeom prst="rect">
@@ -16068,7 +15708,7 @@
         </p:nvSpPr>
         <p:spPr>
           <a:xfrm>
-            <a:off x="548640" y="5413248"/>
+            <a:off x="548640" y="5468112"/>
             <a:ext cx="1188720" cy="274320"/>
           </a:xfrm>
           <a:prstGeom prst="rect">
@@ -16110,7 +15750,7 @@
         </p:nvSpPr>
         <p:spPr>
           <a:xfrm>
-            <a:off x="1783080" y="5486400"/>
+            <a:off x="1783080" y="5541264"/>
             <a:ext cx="1554480" cy="274320"/>
           </a:xfrm>
           <a:prstGeom prst="rect">
@@ -16152,7 +15792,7 @@
         </p:nvSpPr>
         <p:spPr>
           <a:xfrm>
-            <a:off x="3355848" y="5413248"/>
+            <a:off x="3355848" y="5468112"/>
             <a:ext cx="1188720" cy="274320"/>
           </a:xfrm>
           <a:prstGeom prst="rect">
@@ -16194,7 +15834,7 @@
         </p:nvSpPr>
         <p:spPr>
           <a:xfrm>
-            <a:off x="4590288" y="5486400"/>
+            <a:off x="4590288" y="5541264"/>
             <a:ext cx="1554480" cy="274320"/>
           </a:xfrm>
           <a:prstGeom prst="rect">
@@ -16236,7 +15876,7 @@
         </p:nvSpPr>
         <p:spPr>
           <a:xfrm>
-            <a:off x="6163055" y="5413248"/>
+            <a:off x="6163055" y="5468112"/>
             <a:ext cx="1188720" cy="274320"/>
           </a:xfrm>
           <a:prstGeom prst="rect">
@@ -16278,7 +15918,7 @@
         </p:nvSpPr>
         <p:spPr>
           <a:xfrm>
-            <a:off x="7397495" y="5486400"/>
+            <a:off x="7397495" y="5541264"/>
             <a:ext cx="1554480" cy="274320"/>
           </a:xfrm>
           <a:prstGeom prst="rect">
@@ -16320,7 +15960,7 @@
         </p:nvSpPr>
         <p:spPr>
           <a:xfrm>
-            <a:off x="8970263" y="5413248"/>
+            <a:off x="8970263" y="5468112"/>
             <a:ext cx="1188720" cy="274320"/>
           </a:xfrm>
           <a:prstGeom prst="rect">
@@ -16362,7 +16002,7 @@
         </p:nvSpPr>
         <p:spPr>
           <a:xfrm>
-            <a:off x="10204703" y="5486400"/>
+            <a:off x="10204703" y="5541264"/>
             <a:ext cx="1554480" cy="274320"/>
           </a:xfrm>
           <a:prstGeom prst="rect">
@@ -17074,8 +16714,8 @@
         </p:nvSpPr>
         <p:spPr>
           <a:xfrm>
-            <a:off x="621792" y="1984248"/>
-            <a:ext cx="5166360" cy="256032"/>
+            <a:off x="621792" y="1965960"/>
+            <a:ext cx="5120640" cy="246888"/>
           </a:xfrm>
           <a:prstGeom prst="rect">
             <a:avLst/>
@@ -17097,7 +16737,7 @@
               </a:spcAft>
             </a:pPr>
             <a:r>
-              <a:rPr sz="1000" b="1">
+              <a:rPr sz="900" b="1">
                 <a:solidFill>
                   <a:srgbClr val="1E6FBA"/>
                 </a:solidFill>
@@ -17105,7 +16745,39 @@
               </a:rPr>
               <a:t>· </a:t>
             </a:r>
-          </a:p>
+            <a:r>
+              <a:rPr sz="900" b="0">
+                <a:solidFill>
+                  <a:srgbClr val="444C57"/>
+                </a:solidFill>
+                <a:latin typeface="Calibri"/>
+              </a:rPr>
+              <a:t>SIH 2026 Problem Statement 26075 — Ministry of Earth Sciences (MoES) — sih.gov.in</a:t>
+            </a:r>
+          </a:p>
+        </p:txBody>
+      </p:sp>
+      <p:sp>
+        <p:nvSpPr>
+          <p:cNvPr id="18" name="TextBox 17"/>
+          <p:cNvSpPr txBox="1"/>
+          <p:nvPr/>
+        </p:nvSpPr>
+        <p:spPr>
+          <a:xfrm>
+            <a:off x="621792" y="2226563"/>
+            <a:ext cx="5120640" cy="246888"/>
+          </a:xfrm>
+          <a:prstGeom prst="rect">
+            <a:avLst/>
+          </a:prstGeom>
+          <a:noFill/>
+        </p:spPr>
+        <p:txBody>
+          <a:bodyPr wrap="square" lIns="0" rIns="0" tIns="0" bIns="0" anchor="t">
+            <a:spAutoFit/>
+          </a:bodyPr>
+          <a:lstStyle/>
           <a:p>
             <a:pPr algn="l">
               <a:lnSpc>
@@ -17116,27 +16788,36 @@
               </a:spcAft>
             </a:pPr>
             <a:r>
+              <a:rPr sz="900" b="1">
+                <a:solidFill>
+                  <a:srgbClr val="1E6FBA"/>
+                </a:solidFill>
+                <a:latin typeface="Calibri"/>
+              </a:rPr>
+              <a:t>· </a:t>
+            </a:r>
+            <a:r>
               <a:rPr sz="900" b="0">
                 <a:solidFill>
                   <a:srgbClr val="444C57"/>
                 </a:solidFill>
                 <a:latin typeface="Calibri"/>
               </a:rPr>
-              <a:t>SIH 2026 Problem Statement 26075 — Ministry of Earth Sciences (MoES) — sih.gov.in</a:t>
-            </a:r>
-          </a:p>
-        </p:txBody>
-      </p:sp>
-      <p:sp>
-        <p:nvSpPr>
-          <p:cNvPr id="18" name="TextBox 17"/>
-          <p:cNvSpPr txBox="1"/>
-          <p:nvPr/>
-        </p:nvSpPr>
-        <p:spPr>
-          <a:xfrm>
-            <a:off x="621792" y="2249424"/>
-            <a:ext cx="5166360" cy="256032"/>
+              <a:t>moes.gov.in  |  India Meteorological Department — mausam.imd.gov.in</a:t>
+            </a:r>
+          </a:p>
+        </p:txBody>
+      </p:sp>
+      <p:sp>
+        <p:nvSpPr>
+          <p:cNvPr id="19" name="TextBox 18"/>
+          <p:cNvSpPr txBox="1"/>
+          <p:nvPr/>
+        </p:nvSpPr>
+        <p:spPr>
+          <a:xfrm>
+            <a:off x="621792" y="2487166"/>
+            <a:ext cx="5120640" cy="246888"/>
           </a:xfrm>
           <a:prstGeom prst="rect">
             <a:avLst/>
@@ -17158,7 +16839,7 @@
               </a:spcAft>
             </a:pPr>
             <a:r>
-              <a:rPr sz="1000" b="1">
+              <a:rPr sz="900" b="1">
                 <a:solidFill>
                   <a:srgbClr val="1E6FBA"/>
                 </a:solidFill>
@@ -17166,7 +16847,39 @@
               </a:rPr>
               <a:t>· </a:t>
             </a:r>
-          </a:p>
+            <a:r>
+              <a:rPr sz="900" b="0">
+                <a:solidFill>
+                  <a:srgbClr val="444C57"/>
+                </a:solidFill>
+                <a:latin typeface="Calibri"/>
+              </a:rPr>
+              <a:t>MoES Annual Report — capacity building &amp; human-resource development</a:t>
+            </a:r>
+          </a:p>
+        </p:txBody>
+      </p:sp>
+      <p:sp>
+        <p:nvSpPr>
+          <p:cNvPr id="20" name="TextBox 19"/>
+          <p:cNvSpPr txBox="1"/>
+          <p:nvPr/>
+        </p:nvSpPr>
+        <p:spPr>
+          <a:xfrm>
+            <a:off x="621792" y="2747769"/>
+            <a:ext cx="5120640" cy="246888"/>
+          </a:xfrm>
+          <a:prstGeom prst="rect">
+            <a:avLst/>
+          </a:prstGeom>
+          <a:noFill/>
+        </p:spPr>
+        <p:txBody>
+          <a:bodyPr wrap="square" lIns="0" rIns="0" tIns="0" bIns="0" anchor="t">
+            <a:spAutoFit/>
+          </a:bodyPr>
+          <a:lstStyle/>
           <a:p>
             <a:pPr algn="l">
               <a:lnSpc>
@@ -17177,27 +16890,36 @@
               </a:spcAft>
             </a:pPr>
             <a:r>
+              <a:rPr sz="900" b="1">
+                <a:solidFill>
+                  <a:srgbClr val="1E6FBA"/>
+                </a:solidFill>
+                <a:latin typeface="Calibri"/>
+              </a:rPr>
+              <a:t>· </a:t>
+            </a:r>
+            <a:r>
               <a:rPr sz="900" b="0">
                 <a:solidFill>
                   <a:srgbClr val="444C57"/>
                 </a:solidFill>
                 <a:latin typeface="Calibri"/>
               </a:rPr>
-              <a:t>Ministry of Earth Sciences — moes.gov.in  |  India Meteorological Department — mausam.imd.gov.in</a:t>
-            </a:r>
-          </a:p>
-        </p:txBody>
-      </p:sp>
-      <p:sp>
-        <p:nvSpPr>
-          <p:cNvPr id="19" name="TextBox 18"/>
-          <p:cNvSpPr txBox="1"/>
-          <p:nvPr/>
-        </p:nvSpPr>
-        <p:spPr>
-          <a:xfrm>
-            <a:off x="621792" y="2514600"/>
-            <a:ext cx="5166360" cy="256032"/>
+              <a:t>National Education Policy 2020 — digital, competency-based learning</a:t>
+            </a:r>
+          </a:p>
+        </p:txBody>
+      </p:sp>
+      <p:sp>
+        <p:nvSpPr>
+          <p:cNvPr id="21" name="TextBox 20"/>
+          <p:cNvSpPr txBox="1"/>
+          <p:nvPr/>
+        </p:nvSpPr>
+        <p:spPr>
+          <a:xfrm>
+            <a:off x="621792" y="3008372"/>
+            <a:ext cx="5120640" cy="246888"/>
           </a:xfrm>
           <a:prstGeom prst="rect">
             <a:avLst/>
@@ -17219,7 +16941,7 @@
               </a:spcAft>
             </a:pPr>
             <a:r>
-              <a:rPr sz="1000" b="1">
+              <a:rPr sz="900" b="1">
                 <a:solidFill>
                   <a:srgbClr val="1E6FBA"/>
                 </a:solidFill>
@@ -17227,16 +16949,6 @@
               </a:rPr>
               <a:t>· </a:t>
             </a:r>
-          </a:p>
-          <a:p>
-            <a:pPr algn="l">
-              <a:lnSpc>
-                <a:spcPct val="105000"/>
-              </a:lnSpc>
-              <a:spcAft>
-                <a:spcPts val="300"/>
-              </a:spcAft>
-            </a:pPr>
             <a:r>
               <a:rPr sz="900" b="0">
                 <a:solidFill>
@@ -17244,75 +16956,14 @@
                 </a:solidFill>
                 <a:latin typeface="Calibri"/>
               </a:rPr>
-              <a:t>MoES Annual Report — capacity building, training and human-resource development programmes</a:t>
-            </a:r>
-          </a:p>
-        </p:txBody>
-      </p:sp>
-      <p:sp>
-        <p:nvSpPr>
-          <p:cNvPr id="20" name="TextBox 19"/>
-          <p:cNvSpPr txBox="1"/>
-          <p:nvPr/>
-        </p:nvSpPr>
-        <p:spPr>
-          <a:xfrm>
-            <a:off x="621792" y="2779776"/>
-            <a:ext cx="5166360" cy="256032"/>
-          </a:xfrm>
-          <a:prstGeom prst="rect">
-            <a:avLst/>
-          </a:prstGeom>
-          <a:noFill/>
-        </p:spPr>
-        <p:txBody>
-          <a:bodyPr wrap="square" lIns="0" rIns="0" tIns="0" bIns="0" anchor="t">
-            <a:spAutoFit/>
-          </a:bodyPr>
-          <a:lstStyle/>
-          <a:p>
-            <a:pPr algn="l">
-              <a:lnSpc>
-                <a:spcPct val="105000"/>
-              </a:lnSpc>
-              <a:spcAft>
-                <a:spcPts val="300"/>
-              </a:spcAft>
-            </a:pPr>
-            <a:r>
-              <a:rPr sz="1000" b="1">
-                <a:solidFill>
-                  <a:srgbClr val="1E6FBA"/>
-                </a:solidFill>
-                <a:latin typeface="Calibri"/>
-              </a:rPr>
-              <a:t>· </a:t>
-            </a:r>
-          </a:p>
-          <a:p>
-            <a:pPr algn="l">
-              <a:lnSpc>
-                <a:spcPct val="105000"/>
-              </a:lnSpc>
-              <a:spcAft>
-                <a:spcPts val="300"/>
-              </a:spcAft>
-            </a:pPr>
-            <a:r>
-              <a:rPr sz="900" b="0">
-                <a:solidFill>
-                  <a:srgbClr val="444C57"/>
-                </a:solidFill>
-                <a:latin typeface="Calibri"/>
-              </a:rPr>
-              <a:t>National Education Policy 2020 — digital learning, competency-based education and skilling</a:t>
-            </a:r>
-          </a:p>
-        </p:txBody>
-      </p:sp>
-      <p:sp>
-        <p:nvSpPr>
-          <p:cNvPr id="21" name="Rectangle 20"/>
+              <a:t>SIH 2026 portal guidelines — idea submission format and evaluation criteria</a:t>
+            </a:r>
+          </a:p>
+        </p:txBody>
+      </p:sp>
+      <p:sp>
+        <p:nvSpPr>
+          <p:cNvPr id="22" name="Rectangle 21"/>
           <p:cNvSpPr/>
           <p:nvPr/>
         </p:nvSpPr>
@@ -17358,7 +17009,7 @@
       </p:sp>
       <p:sp>
         <p:nvSpPr>
-          <p:cNvPr id="22" name="Rectangle 21"/>
+          <p:cNvPr id="23" name="Rectangle 22"/>
           <p:cNvSpPr/>
           <p:nvPr/>
         </p:nvSpPr>
@@ -17402,7 +17053,7 @@
       </p:sp>
       <p:sp>
         <p:nvSpPr>
-          <p:cNvPr id="23" name="TextBox 22"/>
+          <p:cNvPr id="24" name="TextBox 23"/>
           <p:cNvSpPr txBox="1"/>
           <p:nvPr/>
         </p:nvSpPr>
@@ -17444,14 +17095,14 @@
       </p:sp>
       <p:sp>
         <p:nvSpPr>
-          <p:cNvPr id="24" name="TextBox 23"/>
-          <p:cNvSpPr txBox="1"/>
-          <p:nvPr/>
-        </p:nvSpPr>
-        <p:spPr>
-          <a:xfrm>
-            <a:off x="6336792" y="1984248"/>
-            <a:ext cx="5166360" cy="256032"/>
+          <p:cNvPr id="25" name="TextBox 24"/>
+          <p:cNvSpPr txBox="1"/>
+          <p:nvPr/>
+        </p:nvSpPr>
+        <p:spPr>
+          <a:xfrm>
+            <a:off x="6336792" y="1965960"/>
+            <a:ext cx="5120640" cy="246888"/>
           </a:xfrm>
           <a:prstGeom prst="rect">
             <a:avLst/>
@@ -17473,7 +17124,7 @@
               </a:spcAft>
             </a:pPr>
             <a:r>
-              <a:rPr sz="1000" b="1">
+              <a:rPr sz="900" b="1">
                 <a:solidFill>
                   <a:srgbClr val="F27C1E"/>
                 </a:solidFill>
@@ -17481,7 +17132,39 @@
               </a:rPr>
               <a:t>· </a:t>
             </a:r>
-          </a:p>
+            <a:r>
+              <a:rPr sz="900" b="0">
+                <a:solidFill>
+                  <a:srgbClr val="444C57"/>
+                </a:solidFill>
+                <a:latin typeface="Calibri"/>
+              </a:rPr>
+              <a:t>SCORM / xAPI (Experience API) — learning-record interoperability</a:t>
+            </a:r>
+          </a:p>
+        </p:txBody>
+      </p:sp>
+      <p:sp>
+        <p:nvSpPr>
+          <p:cNvPr id="26" name="TextBox 25"/>
+          <p:cNvSpPr txBox="1"/>
+          <p:nvPr/>
+        </p:nvSpPr>
+        <p:spPr>
+          <a:xfrm>
+            <a:off x="6336792" y="2226563"/>
+            <a:ext cx="5120640" cy="246888"/>
+          </a:xfrm>
+          <a:prstGeom prst="rect">
+            <a:avLst/>
+          </a:prstGeom>
+          <a:noFill/>
+        </p:spPr>
+        <p:txBody>
+          <a:bodyPr wrap="square" lIns="0" rIns="0" tIns="0" bIns="0" anchor="t">
+            <a:spAutoFit/>
+          </a:bodyPr>
+          <a:lstStyle/>
           <a:p>
             <a:pPr algn="l">
               <a:lnSpc>
@@ -17492,27 +17175,36 @@
               </a:spcAft>
             </a:pPr>
             <a:r>
+              <a:rPr sz="900" b="1">
+                <a:solidFill>
+                  <a:srgbClr val="F27C1E"/>
+                </a:solidFill>
+                <a:latin typeface="Calibri"/>
+              </a:rPr>
+              <a:t>· </a:t>
+            </a:r>
+            <a:r>
               <a:rPr sz="900" b="0">
                 <a:solidFill>
                   <a:srgbClr val="444C57"/>
                 </a:solidFill>
                 <a:latin typeface="Calibri"/>
               </a:rPr>
-              <a:t>SCORM / xAPI (Experience API) — learning-record and progress interoperability model</a:t>
-            </a:r>
-          </a:p>
-        </p:txBody>
-      </p:sp>
-      <p:sp>
-        <p:nvSpPr>
-          <p:cNvPr id="25" name="TextBox 24"/>
-          <p:cNvSpPr txBox="1"/>
-          <p:nvPr/>
-        </p:nvSpPr>
-        <p:spPr>
-          <a:xfrm>
-            <a:off x="6336792" y="2249424"/>
-            <a:ext cx="5166360" cy="256032"/>
+              <a:t>IEEE 1484 LOM — learning-object metadata for the course catalog</a:t>
+            </a:r>
+          </a:p>
+        </p:txBody>
+      </p:sp>
+      <p:sp>
+        <p:nvSpPr>
+          <p:cNvPr id="27" name="TextBox 26"/>
+          <p:cNvSpPr txBox="1"/>
+          <p:nvPr/>
+        </p:nvSpPr>
+        <p:spPr>
+          <a:xfrm>
+            <a:off x="6336792" y="2487166"/>
+            <a:ext cx="5120640" cy="246888"/>
           </a:xfrm>
           <a:prstGeom prst="rect">
             <a:avLst/>
@@ -17534,7 +17226,7 @@
               </a:spcAft>
             </a:pPr>
             <a:r>
-              <a:rPr sz="1000" b="1">
+              <a:rPr sz="900" b="1">
                 <a:solidFill>
                   <a:srgbClr val="F27C1E"/>
                 </a:solidFill>
@@ -17542,7 +17234,39 @@
               </a:rPr>
               <a:t>· </a:t>
             </a:r>
-          </a:p>
+            <a:r>
+              <a:rPr sz="900" b="0">
+                <a:solidFill>
+                  <a:srgbClr val="444C57"/>
+                </a:solidFill>
+                <a:latin typeface="Calibri"/>
+              </a:rPr>
+              <a:t>NIST SP 800-63B — digital identity &amp; authentication guidance</a:t>
+            </a:r>
+          </a:p>
+        </p:txBody>
+      </p:sp>
+      <p:sp>
+        <p:nvSpPr>
+          <p:cNvPr id="28" name="TextBox 27"/>
+          <p:cNvSpPr txBox="1"/>
+          <p:nvPr/>
+        </p:nvSpPr>
+        <p:spPr>
+          <a:xfrm>
+            <a:off x="6336792" y="2747769"/>
+            <a:ext cx="5120640" cy="246888"/>
+          </a:xfrm>
+          <a:prstGeom prst="rect">
+            <a:avLst/>
+          </a:prstGeom>
+          <a:noFill/>
+        </p:spPr>
+        <p:txBody>
+          <a:bodyPr wrap="square" lIns="0" rIns="0" tIns="0" bIns="0" anchor="t">
+            <a:spAutoFit/>
+          </a:bodyPr>
+          <a:lstStyle/>
           <a:p>
             <a:pPr algn="l">
               <a:lnSpc>
@@ -17553,27 +17277,36 @@
               </a:spcAft>
             </a:pPr>
             <a:r>
+              <a:rPr sz="900" b="1">
+                <a:solidFill>
+                  <a:srgbClr val="F27C1E"/>
+                </a:solidFill>
+                <a:latin typeface="Calibri"/>
+              </a:rPr>
+              <a:t>· </a:t>
+            </a:r>
+            <a:r>
               <a:rPr sz="900" b="0">
                 <a:solidFill>
                   <a:srgbClr val="444C57"/>
                 </a:solidFill>
                 <a:latin typeface="Calibri"/>
               </a:rPr>
-              <a:t>IEEE 1484 LOM — learning object metadata for the course and document catalog</a:t>
-            </a:r>
-          </a:p>
-        </p:txBody>
-      </p:sp>
-      <p:sp>
-        <p:nvSpPr>
-          <p:cNvPr id="26" name="TextBox 25"/>
-          <p:cNvSpPr txBox="1"/>
-          <p:nvPr/>
-        </p:nvSpPr>
-        <p:spPr>
-          <a:xfrm>
-            <a:off x="6336792" y="2514600"/>
-            <a:ext cx="5166360" cy="256032"/>
+              <a:t>OWASP ASVS + Mobile Top 10 — application security verification baseline</a:t>
+            </a:r>
+          </a:p>
+        </p:txBody>
+      </p:sp>
+      <p:sp>
+        <p:nvSpPr>
+          <p:cNvPr id="29" name="TextBox 28"/>
+          <p:cNvSpPr txBox="1"/>
+          <p:nvPr/>
+        </p:nvSpPr>
+        <p:spPr>
+          <a:xfrm>
+            <a:off x="6336792" y="3008372"/>
+            <a:ext cx="5120640" cy="246888"/>
           </a:xfrm>
           <a:prstGeom prst="rect">
             <a:avLst/>
@@ -17595,7 +17328,7 @@
               </a:spcAft>
             </a:pPr>
             <a:r>
-              <a:rPr sz="1000" b="1">
+              <a:rPr sz="900" b="1">
                 <a:solidFill>
                   <a:srgbClr val="F27C1E"/>
                 </a:solidFill>
@@ -17603,7 +17336,39 @@
               </a:rPr>
               <a:t>· </a:t>
             </a:r>
-          </a:p>
+            <a:r>
+              <a:rPr sz="900" b="0">
+                <a:solidFill>
+                  <a:srgbClr val="444C57"/>
+                </a:solidFill>
+                <a:latin typeface="Calibri"/>
+              </a:rPr>
+              <a:t>NIST SP 800-38D — AES-256-GCM authenticated encryption</a:t>
+            </a:r>
+          </a:p>
+        </p:txBody>
+      </p:sp>
+      <p:sp>
+        <p:nvSpPr>
+          <p:cNvPr id="30" name="TextBox 29"/>
+          <p:cNvSpPr txBox="1"/>
+          <p:nvPr/>
+        </p:nvSpPr>
+        <p:spPr>
+          <a:xfrm>
+            <a:off x="6336792" y="3268975"/>
+            <a:ext cx="5120640" cy="246888"/>
+          </a:xfrm>
+          <a:prstGeom prst="rect">
+            <a:avLst/>
+          </a:prstGeom>
+          <a:noFill/>
+        </p:spPr>
+        <p:txBody>
+          <a:bodyPr wrap="square" lIns="0" rIns="0" tIns="0" bIns="0" anchor="t">
+            <a:spAutoFit/>
+          </a:bodyPr>
+          <a:lstStyle/>
           <a:p>
             <a:pPr algn="l">
               <a:lnSpc>
@@ -17614,203 +17379,29 @@
               </a:spcAft>
             </a:pPr>
             <a:r>
+              <a:rPr sz="900" b="1">
+                <a:solidFill>
+                  <a:srgbClr val="F27C1E"/>
+                </a:solidFill>
+                <a:latin typeface="Calibri"/>
+              </a:rPr>
+              <a:t>· </a:t>
+            </a:r>
+            <a:r>
               <a:rPr sz="900" b="0">
                 <a:solidFill>
                   <a:srgbClr val="444C57"/>
                 </a:solidFill>
                 <a:latin typeface="Calibri"/>
               </a:rPr>
-              <a:t>NIST SP 800-63B — digital identity and authentication guidance (password &amp; session policy)</a:t>
-            </a:r>
-          </a:p>
-        </p:txBody>
-      </p:sp>
-      <p:sp>
-        <p:nvSpPr>
-          <p:cNvPr id="27" name="TextBox 26"/>
-          <p:cNvSpPr txBox="1"/>
-          <p:nvPr/>
-        </p:nvSpPr>
-        <p:spPr>
-          <a:xfrm>
-            <a:off x="6336792" y="2779776"/>
-            <a:ext cx="5166360" cy="256032"/>
-          </a:xfrm>
-          <a:prstGeom prst="rect">
-            <a:avLst/>
-          </a:prstGeom>
-          <a:noFill/>
-        </p:spPr>
-        <p:txBody>
-          <a:bodyPr wrap="square" lIns="0" rIns="0" tIns="0" bIns="0" anchor="t">
-            <a:spAutoFit/>
-          </a:bodyPr>
-          <a:lstStyle/>
-          <a:p>
-            <a:pPr algn="l">
-              <a:lnSpc>
-                <a:spcPct val="105000"/>
-              </a:lnSpc>
-              <a:spcAft>
-                <a:spcPts val="300"/>
-              </a:spcAft>
-            </a:pPr>
-            <a:r>
-              <a:rPr sz="1000" b="1">
-                <a:solidFill>
-                  <a:srgbClr val="F27C1E"/>
-                </a:solidFill>
-                <a:latin typeface="Calibri"/>
-              </a:rPr>
-              <a:t>· </a:t>
-            </a:r>
-          </a:p>
-          <a:p>
-            <a:pPr algn="l">
-              <a:lnSpc>
-                <a:spcPct val="105000"/>
-              </a:lnSpc>
-              <a:spcAft>
-                <a:spcPts val="300"/>
-              </a:spcAft>
-            </a:pPr>
-            <a:r>
-              <a:rPr sz="900" b="0">
-                <a:solidFill>
-                  <a:srgbClr val="444C57"/>
-                </a:solidFill>
-                <a:latin typeface="Calibri"/>
-              </a:rPr>
-              <a:t>OWASP ASVS and OWASP Mobile Top 10 — application security verification baseline</a:t>
-            </a:r>
-          </a:p>
-        </p:txBody>
-      </p:sp>
-      <p:sp>
-        <p:nvSpPr>
-          <p:cNvPr id="28" name="TextBox 27"/>
-          <p:cNvSpPr txBox="1"/>
-          <p:nvPr/>
-        </p:nvSpPr>
-        <p:spPr>
-          <a:xfrm>
-            <a:off x="6336792" y="3044952"/>
-            <a:ext cx="5166360" cy="256032"/>
-          </a:xfrm>
-          <a:prstGeom prst="rect">
-            <a:avLst/>
-          </a:prstGeom>
-          <a:noFill/>
-        </p:spPr>
-        <p:txBody>
-          <a:bodyPr wrap="square" lIns="0" rIns="0" tIns="0" bIns="0" anchor="t">
-            <a:spAutoFit/>
-          </a:bodyPr>
-          <a:lstStyle/>
-          <a:p>
-            <a:pPr algn="l">
-              <a:lnSpc>
-                <a:spcPct val="105000"/>
-              </a:lnSpc>
-              <a:spcAft>
-                <a:spcPts val="300"/>
-              </a:spcAft>
-            </a:pPr>
-            <a:r>
-              <a:rPr sz="1000" b="1">
-                <a:solidFill>
-                  <a:srgbClr val="F27C1E"/>
-                </a:solidFill>
-                <a:latin typeface="Calibri"/>
-              </a:rPr>
-              <a:t>· </a:t>
-            </a:r>
-          </a:p>
-          <a:p>
-            <a:pPr algn="l">
-              <a:lnSpc>
-                <a:spcPct val="105000"/>
-              </a:lnSpc>
-              <a:spcAft>
-                <a:spcPts val="300"/>
-              </a:spcAft>
-            </a:pPr>
-            <a:r>
-              <a:rPr sz="900" b="0">
-                <a:solidFill>
-                  <a:srgbClr val="444C57"/>
-                </a:solidFill>
-                <a:latin typeface="Calibri"/>
-              </a:rPr>
-              <a:t>NIST SP 800-38D — AES-256-GCM authenticated encryption</a:t>
-            </a:r>
-          </a:p>
-        </p:txBody>
-      </p:sp>
-      <p:sp>
-        <p:nvSpPr>
-          <p:cNvPr id="29" name="TextBox 28"/>
-          <p:cNvSpPr txBox="1"/>
-          <p:nvPr/>
-        </p:nvSpPr>
-        <p:spPr>
-          <a:xfrm>
-            <a:off x="6336792" y="3310128"/>
-            <a:ext cx="5166360" cy="256032"/>
-          </a:xfrm>
-          <a:prstGeom prst="rect">
-            <a:avLst/>
-          </a:prstGeom>
-          <a:noFill/>
-        </p:spPr>
-        <p:txBody>
-          <a:bodyPr wrap="square" lIns="0" rIns="0" tIns="0" bIns="0" anchor="t">
-            <a:spAutoFit/>
-          </a:bodyPr>
-          <a:lstStyle/>
-          <a:p>
-            <a:pPr algn="l">
-              <a:lnSpc>
-                <a:spcPct val="105000"/>
-              </a:lnSpc>
-              <a:spcAft>
-                <a:spcPts val="300"/>
-              </a:spcAft>
-            </a:pPr>
-            <a:r>
-              <a:rPr sz="1000" b="1">
-                <a:solidFill>
-                  <a:srgbClr val="F27C1E"/>
-                </a:solidFill>
-                <a:latin typeface="Calibri"/>
-              </a:rPr>
-              <a:t>· </a:t>
-            </a:r>
-          </a:p>
-          <a:p>
-            <a:pPr algn="l">
-              <a:lnSpc>
-                <a:spcPct val="105000"/>
-              </a:lnSpc>
-              <a:spcAft>
-                <a:spcPts val="300"/>
-              </a:spcAft>
-            </a:pPr>
-            <a:r>
-              <a:rPr sz="900" b="0">
-                <a:solidFill>
-                  <a:srgbClr val="444C57"/>
-                </a:solidFill>
-                <a:latin typeface="Calibri"/>
-              </a:rPr>
-              <a:t>ISO/IEC 27001 Annex A — access control, logging and audit-trail controls</a:t>
-            </a:r>
-          </a:p>
-        </p:txBody>
-      </p:sp>
-      <p:sp>
-        <p:nvSpPr>
-          <p:cNvPr id="30" name="Rectangle 29"/>
+              <a:t>ISO/IEC 27001 Annex A — access control, logging, audit-trail controls</a:t>
+            </a:r>
+          </a:p>
+        </p:txBody>
+      </p:sp>
+      <p:sp>
+        <p:nvSpPr>
+          <p:cNvPr id="31" name="Rectangle 30"/>
           <p:cNvSpPr/>
           <p:nvPr/>
         </p:nvSpPr>
@@ -17856,7 +17447,7 @@
       </p:sp>
       <p:sp>
         <p:nvSpPr>
-          <p:cNvPr id="31" name="Rectangle 30"/>
+          <p:cNvPr id="32" name="Rectangle 31"/>
           <p:cNvSpPr/>
           <p:nvPr/>
         </p:nvSpPr>
@@ -17900,7 +17491,7 @@
       </p:sp>
       <p:sp>
         <p:nvSpPr>
-          <p:cNvPr id="32" name="TextBox 31"/>
+          <p:cNvPr id="33" name="TextBox 32"/>
           <p:cNvSpPr txBox="1"/>
           <p:nvPr/>
         </p:nvSpPr>
@@ -17942,14 +17533,14 @@
       </p:sp>
       <p:sp>
         <p:nvSpPr>
-          <p:cNvPr id="33" name="TextBox 32"/>
-          <p:cNvSpPr txBox="1"/>
-          <p:nvPr/>
-        </p:nvSpPr>
-        <p:spPr>
-          <a:xfrm>
-            <a:off x="621792" y="4224528"/>
-            <a:ext cx="5166360" cy="256032"/>
+          <p:cNvPr id="34" name="TextBox 33"/>
+          <p:cNvSpPr txBox="1"/>
+          <p:nvPr/>
+        </p:nvSpPr>
+        <p:spPr>
+          <a:xfrm>
+            <a:off x="621792" y="4206240"/>
+            <a:ext cx="5120640" cy="246888"/>
           </a:xfrm>
           <a:prstGeom prst="rect">
             <a:avLst/>
@@ -17971,7 +17562,7 @@
               </a:spcAft>
             </a:pPr>
             <a:r>
-              <a:rPr sz="1000" b="1">
+              <a:rPr sz="900" b="1">
                 <a:solidFill>
                   <a:srgbClr val="2E8B57"/>
                 </a:solidFill>
@@ -17979,7 +17570,39 @@
               </a:rPr>
               <a:t>· </a:t>
             </a:r>
-          </a:p>
+            <a:r>
+              <a:rPr sz="900" b="0">
+                <a:solidFill>
+                  <a:srgbClr val="444C57"/>
+                </a:solidFill>
+                <a:latin typeface="Calibri"/>
+              </a:rPr>
+              <a:t>Flutter &amp; Dart — docs.flutter.dev | Riverpod, GoRouter, Drift</a:t>
+            </a:r>
+          </a:p>
+        </p:txBody>
+      </p:sp>
+      <p:sp>
+        <p:nvSpPr>
+          <p:cNvPr id="35" name="TextBox 34"/>
+          <p:cNvSpPr txBox="1"/>
+          <p:nvPr/>
+        </p:nvSpPr>
+        <p:spPr>
+          <a:xfrm>
+            <a:off x="621792" y="4466843"/>
+            <a:ext cx="5120640" cy="246888"/>
+          </a:xfrm>
+          <a:prstGeom prst="rect">
+            <a:avLst/>
+          </a:prstGeom>
+          <a:noFill/>
+        </p:spPr>
+        <p:txBody>
+          <a:bodyPr wrap="square" lIns="0" rIns="0" tIns="0" bIns="0" anchor="t">
+            <a:spAutoFit/>
+          </a:bodyPr>
+          <a:lstStyle/>
           <a:p>
             <a:pPr algn="l">
               <a:lnSpc>
@@ -17990,27 +17613,36 @@
               </a:spcAft>
             </a:pPr>
             <a:r>
+              <a:rPr sz="900" b="1">
+                <a:solidFill>
+                  <a:srgbClr val="2E8B57"/>
+                </a:solidFill>
+                <a:latin typeface="Calibri"/>
+              </a:rPr>
+              <a:t>· </a:t>
+            </a:r>
+            <a:r>
               <a:rPr sz="900" b="0">
                 <a:solidFill>
                   <a:srgbClr val="444C57"/>
                 </a:solidFill>
                 <a:latin typeface="Calibri"/>
               </a:rPr>
-              <a:t>Flutter &amp; Dart — docs.flutter.dev  |  Riverpod, GoRouter, Drift (drift.simonbinder.eu)</a:t>
-            </a:r>
-          </a:p>
-        </p:txBody>
-      </p:sp>
-      <p:sp>
-        <p:nvSpPr>
-          <p:cNvPr id="34" name="TextBox 33"/>
-          <p:cNvSpPr txBox="1"/>
-          <p:nvPr/>
-        </p:nvSpPr>
-        <p:spPr>
-          <a:xfrm>
-            <a:off x="621792" y="4489704"/>
-            <a:ext cx="5166360" cy="256032"/>
+              <a:t>FastAPI — fastapi.tiangolo.com  |  SQLAlchemy, Alembic, Pydantic official docs</a:t>
+            </a:r>
+          </a:p>
+        </p:txBody>
+      </p:sp>
+      <p:sp>
+        <p:nvSpPr>
+          <p:cNvPr id="36" name="TextBox 35"/>
+          <p:cNvSpPr txBox="1"/>
+          <p:nvPr/>
+        </p:nvSpPr>
+        <p:spPr>
+          <a:xfrm>
+            <a:off x="621792" y="4727446"/>
+            <a:ext cx="5120640" cy="246888"/>
           </a:xfrm>
           <a:prstGeom prst="rect">
             <a:avLst/>
@@ -18032,7 +17664,7 @@
               </a:spcAft>
             </a:pPr>
             <a:r>
-              <a:rPr sz="1000" b="1">
+              <a:rPr sz="900" b="1">
                 <a:solidFill>
                   <a:srgbClr val="2E8B57"/>
                 </a:solidFill>
@@ -18040,7 +17672,39 @@
               </a:rPr>
               <a:t>· </a:t>
             </a:r>
-          </a:p>
+            <a:r>
+              <a:rPr sz="900" b="0">
+                <a:solidFill>
+                  <a:srgbClr val="444C57"/>
+                </a:solidFill>
+                <a:latin typeface="Calibri"/>
+              </a:rPr>
+              <a:t>SQLCipher — full-database encryption for SQLite (zetetic.net/sqlcipher)</a:t>
+            </a:r>
+          </a:p>
+        </p:txBody>
+      </p:sp>
+      <p:sp>
+        <p:nvSpPr>
+          <p:cNvPr id="37" name="TextBox 36"/>
+          <p:cNvSpPr txBox="1"/>
+          <p:nvPr/>
+        </p:nvSpPr>
+        <p:spPr>
+          <a:xfrm>
+            <a:off x="621792" y="4988049"/>
+            <a:ext cx="5120640" cy="246888"/>
+          </a:xfrm>
+          <a:prstGeom prst="rect">
+            <a:avLst/>
+          </a:prstGeom>
+          <a:noFill/>
+        </p:spPr>
+        <p:txBody>
+          <a:bodyPr wrap="square" lIns="0" rIns="0" tIns="0" bIns="0" anchor="t">
+            <a:spAutoFit/>
+          </a:bodyPr>
+          <a:lstStyle/>
           <a:p>
             <a:pPr algn="l">
               <a:lnSpc>
@@ -18051,27 +17715,36 @@
               </a:spcAft>
             </a:pPr>
             <a:r>
+              <a:rPr sz="900" b="1">
+                <a:solidFill>
+                  <a:srgbClr val="2E8B57"/>
+                </a:solidFill>
+                <a:latin typeface="Calibri"/>
+              </a:rPr>
+              <a:t>· </a:t>
+            </a:r>
+            <a:r>
               <a:rPr sz="900" b="0">
                 <a:solidFill>
                   <a:srgbClr val="444C57"/>
                 </a:solidFill>
                 <a:latin typeface="Calibri"/>
               </a:rPr>
-              <a:t>FastAPI — fastapi.tiangolo.com  |  SQLAlchemy, Alembic, Pydantic official docs</a:t>
-            </a:r>
-          </a:p>
-        </p:txBody>
-      </p:sp>
-      <p:sp>
-        <p:nvSpPr>
-          <p:cNvPr id="35" name="TextBox 34"/>
-          <p:cNvSpPr txBox="1"/>
-          <p:nvPr/>
-        </p:nvSpPr>
-        <p:spPr>
-          <a:xfrm>
-            <a:off x="621792" y="4754880"/>
-            <a:ext cx="5166360" cy="256032"/>
+              <a:t>Khronos glTF 2.0 specification — 3D asset format for the Digital Twin</a:t>
+            </a:r>
+          </a:p>
+        </p:txBody>
+      </p:sp>
+      <p:sp>
+        <p:nvSpPr>
+          <p:cNvPr id="38" name="TextBox 37"/>
+          <p:cNvSpPr txBox="1"/>
+          <p:nvPr/>
+        </p:nvSpPr>
+        <p:spPr>
+          <a:xfrm>
+            <a:off x="621792" y="5248652"/>
+            <a:ext cx="5120640" cy="246888"/>
           </a:xfrm>
           <a:prstGeom prst="rect">
             <a:avLst/>
@@ -18093,7 +17766,7 @@
               </a:spcAft>
             </a:pPr>
             <a:r>
-              <a:rPr sz="1000" b="1">
+              <a:rPr sz="900" b="1">
                 <a:solidFill>
                   <a:srgbClr val="2E8B57"/>
                 </a:solidFill>
@@ -18101,16 +17774,6 @@
               </a:rPr>
               <a:t>· </a:t>
             </a:r>
-          </a:p>
-          <a:p>
-            <a:pPr algn="l">
-              <a:lnSpc>
-                <a:spcPct val="105000"/>
-              </a:lnSpc>
-              <a:spcAft>
-                <a:spcPts val="300"/>
-              </a:spcAft>
-            </a:pPr>
             <a:r>
               <a:rPr sz="900" b="0">
                 <a:solidFill>
@@ -18118,136 +17781,14 @@
                 </a:solidFill>
                 <a:latin typeface="Calibri"/>
               </a:rPr>
-              <a:t>SQLCipher — full-database encryption for SQLite (zetetic.net/sqlcipher)</a:t>
-            </a:r>
-          </a:p>
-        </p:txBody>
-      </p:sp>
-      <p:sp>
-        <p:nvSpPr>
-          <p:cNvPr id="36" name="TextBox 35"/>
-          <p:cNvSpPr txBox="1"/>
-          <p:nvPr/>
-        </p:nvSpPr>
-        <p:spPr>
-          <a:xfrm>
-            <a:off x="621792" y="5020056"/>
-            <a:ext cx="5166360" cy="256032"/>
-          </a:xfrm>
-          <a:prstGeom prst="rect">
-            <a:avLst/>
-          </a:prstGeom>
-          <a:noFill/>
-        </p:spPr>
-        <p:txBody>
-          <a:bodyPr wrap="square" lIns="0" rIns="0" tIns="0" bIns="0" anchor="t">
-            <a:spAutoFit/>
-          </a:bodyPr>
-          <a:lstStyle/>
-          <a:p>
-            <a:pPr algn="l">
-              <a:lnSpc>
-                <a:spcPct val="105000"/>
-              </a:lnSpc>
-              <a:spcAft>
-                <a:spcPts val="300"/>
-              </a:spcAft>
-            </a:pPr>
-            <a:r>
-              <a:rPr sz="1000" b="1">
-                <a:solidFill>
-                  <a:srgbClr val="2E8B57"/>
-                </a:solidFill>
-                <a:latin typeface="Calibri"/>
-              </a:rPr>
-              <a:t>· </a:t>
-            </a:r>
-          </a:p>
-          <a:p>
-            <a:pPr algn="l">
-              <a:lnSpc>
-                <a:spcPct val="105000"/>
-              </a:lnSpc>
-              <a:spcAft>
-                <a:spcPts val="300"/>
-              </a:spcAft>
-            </a:pPr>
-            <a:r>
-              <a:rPr sz="900" b="0">
-                <a:solidFill>
-                  <a:srgbClr val="444C57"/>
-                </a:solidFill>
-                <a:latin typeface="Calibri"/>
-              </a:rPr>
-              <a:t>Khronos glTF 2.0 specification — 3D asset format for the Digital Twin</a:t>
-            </a:r>
-          </a:p>
-        </p:txBody>
-      </p:sp>
-      <p:sp>
-        <p:nvSpPr>
-          <p:cNvPr id="37" name="TextBox 36"/>
-          <p:cNvSpPr txBox="1"/>
-          <p:nvPr/>
-        </p:nvSpPr>
-        <p:spPr>
-          <a:xfrm>
-            <a:off x="621792" y="5285232"/>
-            <a:ext cx="5166360" cy="256032"/>
-          </a:xfrm>
-          <a:prstGeom prst="rect">
-            <a:avLst/>
-          </a:prstGeom>
-          <a:noFill/>
-        </p:spPr>
-        <p:txBody>
-          <a:bodyPr wrap="square" lIns="0" rIns="0" tIns="0" bIns="0" anchor="t">
-            <a:spAutoFit/>
-          </a:bodyPr>
-          <a:lstStyle/>
-          <a:p>
-            <a:pPr algn="l">
-              <a:lnSpc>
-                <a:spcPct val="105000"/>
-              </a:lnSpc>
-              <a:spcAft>
-                <a:spcPts val="300"/>
-              </a:spcAft>
-            </a:pPr>
-            <a:r>
-              <a:rPr sz="1000" b="1">
-                <a:solidFill>
-                  <a:srgbClr val="2E8B57"/>
-                </a:solidFill>
-                <a:latin typeface="Calibri"/>
-              </a:rPr>
-              <a:t>· </a:t>
-            </a:r>
-          </a:p>
-          <a:p>
-            <a:pPr algn="l">
-              <a:lnSpc>
-                <a:spcPct val="105000"/>
-              </a:lnSpc>
-              <a:spcAft>
-                <a:spcPts val="300"/>
-              </a:spcAft>
-            </a:pPr>
-            <a:r>
-              <a:rPr sz="900" b="0">
-                <a:solidFill>
-                  <a:srgbClr val="444C57"/>
-                </a:solidFill>
-                <a:latin typeface="Calibri"/>
-              </a:rPr>
-              <a:t>PostgreSQL 16 documentation  |  Docker Compose deployment reference</a:t>
-            </a:r>
-          </a:p>
-        </p:txBody>
-      </p:sp>
-      <p:sp>
-        <p:nvSpPr>
-          <p:cNvPr id="38" name="Rectangle 37"/>
+              <a:t>PostgreSQL 16 docs | Docker Compose deployment reference</a:t>
+            </a:r>
+          </a:p>
+        </p:txBody>
+      </p:sp>
+      <p:sp>
+        <p:nvSpPr>
+          <p:cNvPr id="39" name="Rectangle 38"/>
           <p:cNvSpPr/>
           <p:nvPr/>
         </p:nvSpPr>
@@ -18293,7 +17834,7 @@
       </p:sp>
       <p:sp>
         <p:nvSpPr>
-          <p:cNvPr id="39" name="Rectangle 38"/>
+          <p:cNvPr id="40" name="Rectangle 39"/>
           <p:cNvSpPr/>
           <p:nvPr/>
         </p:nvSpPr>
@@ -18337,7 +17878,7 @@
       </p:sp>
       <p:sp>
         <p:nvSpPr>
-          <p:cNvPr id="40" name="TextBox 39"/>
+          <p:cNvPr id="41" name="TextBox 40"/>
           <p:cNvSpPr txBox="1"/>
           <p:nvPr/>
         </p:nvSpPr>
@@ -18379,14 +17920,14 @@
       </p:sp>
       <p:sp>
         <p:nvSpPr>
-          <p:cNvPr id="41" name="TextBox 40"/>
-          <p:cNvSpPr txBox="1"/>
-          <p:nvPr/>
-        </p:nvSpPr>
-        <p:spPr>
-          <a:xfrm>
-            <a:off x="6336792" y="4224528"/>
-            <a:ext cx="5166360" cy="256032"/>
+          <p:cNvPr id="42" name="TextBox 41"/>
+          <p:cNvSpPr txBox="1"/>
+          <p:nvPr/>
+        </p:nvSpPr>
+        <p:spPr>
+          <a:xfrm>
+            <a:off x="6336792" y="4206240"/>
+            <a:ext cx="5120640" cy="246888"/>
           </a:xfrm>
           <a:prstGeom prst="rect">
             <a:avLst/>
@@ -18408,7 +17949,7 @@
               </a:spcAft>
             </a:pPr>
             <a:r>
-              <a:rPr sz="1000" b="1">
+              <a:rPr sz="900" b="1">
                 <a:solidFill>
                   <a:srgbClr val="1F3864"/>
                 </a:solidFill>
@@ -18416,7 +17957,39 @@
               </a:rPr>
               <a:t>· </a:t>
             </a:r>
-          </a:p>
+            <a:r>
+              <a:rPr sz="900" b="0">
+                <a:solidFill>
+                  <a:srgbClr val="444C57"/>
+                </a:solidFill>
+                <a:latin typeface="Calibri"/>
+              </a:rPr>
+              <a:t>Digital Twin concepts for marine instrumentation (ISO 23247 framing)</a:t>
+            </a:r>
+          </a:p>
+        </p:txBody>
+      </p:sp>
+      <p:sp>
+        <p:nvSpPr>
+          <p:cNvPr id="43" name="TextBox 42"/>
+          <p:cNvSpPr txBox="1"/>
+          <p:nvPr/>
+        </p:nvSpPr>
+        <p:spPr>
+          <a:xfrm>
+            <a:off x="6336792" y="4466843"/>
+            <a:ext cx="5120640" cy="246888"/>
+          </a:xfrm>
+          <a:prstGeom prst="rect">
+            <a:avLst/>
+          </a:prstGeom>
+          <a:noFill/>
+        </p:spPr>
+        <p:txBody>
+          <a:bodyPr wrap="square" lIns="0" rIns="0" tIns="0" bIns="0" anchor="t">
+            <a:spAutoFit/>
+          </a:bodyPr>
+          <a:lstStyle/>
           <a:p>
             <a:pPr algn="l">
               <a:lnSpc>
@@ -18427,27 +18000,36 @@
               </a:spcAft>
             </a:pPr>
             <a:r>
+              <a:rPr sz="900" b="1">
+                <a:solidFill>
+                  <a:srgbClr val="1F3864"/>
+                </a:solidFill>
+                <a:latin typeface="Calibri"/>
+              </a:rPr>
+              <a:t>· </a:t>
+            </a:r>
+            <a:r>
               <a:rPr sz="900" b="0">
                 <a:solidFill>
                   <a:srgbClr val="444C57"/>
                 </a:solidFill>
                 <a:latin typeface="Calibri"/>
               </a:rPr>
-              <a:t>Digital Twin concepts for marine and oceanographic instrumentation (ISO 23247 asset-twin framing)</a:t>
-            </a:r>
-          </a:p>
-        </p:txBody>
-      </p:sp>
-      <p:sp>
-        <p:nvSpPr>
-          <p:cNvPr id="42" name="TextBox 41"/>
-          <p:cNvSpPr txBox="1"/>
-          <p:nvPr/>
-        </p:nvSpPr>
-        <p:spPr>
-          <a:xfrm>
-            <a:off x="6336792" y="4489704"/>
-            <a:ext cx="5166360" cy="256032"/>
+              <a:t>Argo programme documentation — argo.ucsd.edu — float operations</a:t>
+            </a:r>
+          </a:p>
+        </p:txBody>
+      </p:sp>
+      <p:sp>
+        <p:nvSpPr>
+          <p:cNvPr id="44" name="TextBox 43"/>
+          <p:cNvSpPr txBox="1"/>
+          <p:nvPr/>
+        </p:nvSpPr>
+        <p:spPr>
+          <a:xfrm>
+            <a:off x="6336792" y="4727446"/>
+            <a:ext cx="5120640" cy="246888"/>
           </a:xfrm>
           <a:prstGeom prst="rect">
             <a:avLst/>
@@ -18469,7 +18051,7 @@
               </a:spcAft>
             </a:pPr>
             <a:r>
-              <a:rPr sz="1000" b="1">
+              <a:rPr sz="900" b="1">
                 <a:solidFill>
                   <a:srgbClr val="1F3864"/>
                 </a:solidFill>
@@ -18477,7 +18059,39 @@
               </a:rPr>
               <a:t>· </a:t>
             </a:r>
-          </a:p>
+            <a:r>
+              <a:rPr sz="900" b="0">
+                <a:solidFill>
+                  <a:srgbClr val="444C57"/>
+                </a:solidFill>
+                <a:latin typeface="Calibri"/>
+              </a:rPr>
+              <a:t>Offline-first patterns; CRDT vs. ledger-based synchronisation literature</a:t>
+            </a:r>
+          </a:p>
+        </p:txBody>
+      </p:sp>
+      <p:sp>
+        <p:nvSpPr>
+          <p:cNvPr id="45" name="TextBox 44"/>
+          <p:cNvSpPr txBox="1"/>
+          <p:nvPr/>
+        </p:nvSpPr>
+        <p:spPr>
+          <a:xfrm>
+            <a:off x="6336792" y="4988049"/>
+            <a:ext cx="5120640" cy="246888"/>
+          </a:xfrm>
+          <a:prstGeom prst="rect">
+            <a:avLst/>
+          </a:prstGeom>
+          <a:noFill/>
+        </p:spPr>
+        <p:txBody>
+          <a:bodyPr wrap="square" lIns="0" rIns="0" tIns="0" bIns="0" anchor="t">
+            <a:spAutoFit/>
+          </a:bodyPr>
+          <a:lstStyle/>
           <a:p>
             <a:pPr algn="l">
               <a:lnSpc>
@@ -18488,27 +18102,36 @@
               </a:spcAft>
             </a:pPr>
             <a:r>
+              <a:rPr sz="900" b="1">
+                <a:solidFill>
+                  <a:srgbClr val="1F3864"/>
+                </a:solidFill>
+                <a:latin typeface="Calibri"/>
+              </a:rPr>
+              <a:t>· </a:t>
+            </a:r>
+            <a:r>
               <a:rPr sz="900" b="0">
                 <a:solidFill>
                   <a:srgbClr val="444C57"/>
                 </a:solidFill>
                 <a:latin typeface="Calibri"/>
               </a:rPr>
-              <a:t>Argo programme float documentation — argo.ucsd.edu — profiling float operations &amp; maintenance</a:t>
-            </a:r>
-          </a:p>
-        </p:txBody>
-      </p:sp>
-      <p:sp>
-        <p:nvSpPr>
-          <p:cNvPr id="43" name="TextBox 42"/>
-          <p:cNvSpPr txBox="1"/>
-          <p:nvPr/>
-        </p:nvSpPr>
-        <p:spPr>
-          <a:xfrm>
-            <a:off x="6336792" y="4754880"/>
-            <a:ext cx="5166360" cy="256032"/>
+              <a:t>Open-source LMS study (Moodle, Open edX) — role model &amp; gap analysis</a:t>
+            </a:r>
+          </a:p>
+        </p:txBody>
+      </p:sp>
+      <p:sp>
+        <p:nvSpPr>
+          <p:cNvPr id="46" name="TextBox 45"/>
+          <p:cNvSpPr txBox="1"/>
+          <p:nvPr/>
+        </p:nvSpPr>
+        <p:spPr>
+          <a:xfrm>
+            <a:off x="6336792" y="5248652"/>
+            <a:ext cx="5120640" cy="246888"/>
           </a:xfrm>
           <a:prstGeom prst="rect">
             <a:avLst/>
@@ -18530,7 +18153,7 @@
               </a:spcAft>
             </a:pPr>
             <a:r>
-              <a:rPr sz="1000" b="1">
+              <a:rPr sz="900" b="1">
                 <a:solidFill>
                   <a:srgbClr val="1F3864"/>
                 </a:solidFill>
@@ -18538,16 +18161,6 @@
               </a:rPr>
               <a:t>· </a:t>
             </a:r>
-          </a:p>
-          <a:p>
-            <a:pPr algn="l">
-              <a:lnSpc>
-                <a:spcPct val="105000"/>
-              </a:lnSpc>
-              <a:spcAft>
-                <a:spcPts val="300"/>
-              </a:spcAft>
-            </a:pPr>
             <a:r>
               <a:rPr sz="900" b="0">
                 <a:solidFill>
@@ -18555,75 +18168,14 @@
                 </a:solidFill>
                 <a:latin typeface="Calibri"/>
               </a:rPr>
-              <a:t>Offline-first / local-first application patterns and CRDT vs. ledger-based sync literature</a:t>
-            </a:r>
-          </a:p>
-        </p:txBody>
-      </p:sp>
-      <p:sp>
-        <p:nvSpPr>
-          <p:cNvPr id="44" name="TextBox 43"/>
-          <p:cNvSpPr txBox="1"/>
-          <p:nvPr/>
-        </p:nvSpPr>
-        <p:spPr>
-          <a:xfrm>
-            <a:off x="6336792" y="5020056"/>
-            <a:ext cx="5166360" cy="256032"/>
-          </a:xfrm>
-          <a:prstGeom prst="rect">
-            <a:avLst/>
-          </a:prstGeom>
-          <a:noFill/>
-        </p:spPr>
-        <p:txBody>
-          <a:bodyPr wrap="square" lIns="0" rIns="0" tIns="0" bIns="0" anchor="t">
-            <a:spAutoFit/>
-          </a:bodyPr>
-          <a:lstStyle/>
-          <a:p>
-            <a:pPr algn="l">
-              <a:lnSpc>
-                <a:spcPct val="105000"/>
-              </a:lnSpc>
-              <a:spcAft>
-                <a:spcPts val="300"/>
-              </a:spcAft>
-            </a:pPr>
-            <a:r>
-              <a:rPr sz="1000" b="1">
-                <a:solidFill>
-                  <a:srgbClr val="1F3864"/>
-                </a:solidFill>
-                <a:latin typeface="Calibri"/>
-              </a:rPr>
-              <a:t>· </a:t>
-            </a:r>
-          </a:p>
-          <a:p>
-            <a:pPr algn="l">
-              <a:lnSpc>
-                <a:spcPct val="105000"/>
-              </a:lnSpc>
-              <a:spcAft>
-                <a:spcPts val="300"/>
-              </a:spcAft>
-            </a:pPr>
-            <a:r>
-              <a:rPr sz="900" b="0">
-                <a:solidFill>
-                  <a:srgbClr val="444C57"/>
-                </a:solidFill>
-                <a:latin typeface="Calibri"/>
-              </a:rPr>
-              <a:t>Open-source LMS comparison (Moodle, Open edX) — informed the role model and gap analysis</a:t>
-            </a:r>
-          </a:p>
-        </p:txBody>
-      </p:sp>
-      <p:sp>
-        <p:nvSpPr>
-          <p:cNvPr id="45" name="TextBox 44"/>
+              <a:t>RapidFuzz / TF-IDF retrieval literature — basis of the confidence score</a:t>
+            </a:r>
+          </a:p>
+        </p:txBody>
+      </p:sp>
+      <p:sp>
+        <p:nvSpPr>
+          <p:cNvPr id="47" name="TextBox 46"/>
           <p:cNvSpPr txBox="1"/>
           <p:nvPr/>
         </p:nvSpPr>
@@ -18660,16 +18212,6 @@
               </a:rPr>
               <a:t>Note: </a:t>
             </a:r>
-          </a:p>
-          <a:p>
-            <a:pPr algn="l">
-              <a:lnSpc>
-                <a:spcPct val="108000"/>
-              </a:lnSpc>
-              <a:spcAft>
-                <a:spcPts val="300"/>
-              </a:spcAft>
-            </a:pPr>
             <a:r>
               <a:rPr sz="950" b="0">
                 <a:solidFill>

</xml_diff>